<commit_message>
Owner edit: strip em dashes across Kit 1; add dash rule to Kit Standard
- ~335 em dashes recast individually as periods, colons, commas,
  semicolons, or parentheses across all 9 components and the deck
- Four earned dashes kept (spoken pushback line, signature close,
  two speech-rhythm quotes)
- Labels and titles now use ':' or '·'; founder slot tags use '·'
- Kit Standard + humanization checklist updated with the owner's
  dash rule so future kits are written this way from the start

Co-Authored-By: Claude Opus 5 <noreply@anthropic.com>
Claude-Session: https://claude.ai/code/session_01UrWWr3vbRywthE5aNZWdnr
</commit_message>
<xml_diff>
--- a/kits/kit01/Kit01_PresentationDeck.pptx
+++ b/kits/kit01/Kit01_PresentationDeck.pptx
@@ -531,7 +531,7 @@
           <a:p>
             <a:r>
               <a:rPr lang="en-US" dirty="0"/>
-              <a:t>Have this slide up as people arrive. Start on time. Script: "Welcome, everyone…" — the full word-for-word text is in the Facilitator Script, keyed to every slide number.</a:t>
+              <a:t>Have this slide up as people arrive. Start on time. Script: "Welcome, everyone…". The full word-for-word text is in the Facilitator Script, keyed to every slide number.</a:t>
             </a:r>
             <a:endParaRPr lang="en-US" dirty="0"/>
           </a:p>
@@ -707,7 +707,7 @@
           <a:p>
             <a:r>
               <a:rPr lang="en-US" dirty="0"/>
-              <a:t>The obvious things — then widen it: anything from a record or about a specific child stays out of the chat box.</a:t>
+              <a:t>The obvious things first, then widen it: anything from a record or about a specific child stays out of the chat box.</a:t>
             </a:r>
             <a:endParaRPr lang="en-US" dirty="0"/>
           </a:p>
@@ -795,7 +795,7 @@
           <a:p>
             <a:r>
               <a:rPr lang="en-US" dirty="0"/>
-              <a:t>If asked "even in a private chat that I delete?" — yes. Deleting your view doesn’t recall what the company received. The rule works because it has no exceptions to remember at 9pm on a Sunday.</a:t>
+              <a:t>If asked "even in a private chat that I delete?": yes. Deleting your view doesn’t recall what the company received. The rule works because it has no exceptions to remember at 9pm on a Sunday.</a:t>
             </a:r>
             <a:endParaRPr lang="en-US" dirty="0"/>
           </a:p>
@@ -1059,7 +1059,7 @@
           <a:p>
             <a:r>
               <a:rPr lang="en-US" dirty="0"/>
-              <a:t>Transition slide — quick. The de-identification skill on the next slides is what makes the rule cost nothing in practice.</a:t>
+              <a:t>Transition slide; keep it quick. The de-identification skill on the next slides is what makes the rule cost nothing in practice.</a:t>
             </a:r>
             <a:endParaRPr lang="en-US" dirty="0"/>
           </a:p>
@@ -1147,7 +1147,7 @@
           <a:p>
             <a:r>
               <a:rPr lang="en-US" dirty="0"/>
-              <a:t>The unsafe version pastes a full student record — name, family, academics, behavior — into a stranger’s text box. The safe version gets the same email; the AI needed the situation, never the child. Add the name after it’s back in your own email account.</a:t>
+              <a:t>The unsafe version pastes a full student record (name, family, academics, behavior) into a stranger’s text box. The safe version gets the same email; the AI needed the situation, never the child. Add the name after it’s back in your own email account.</a:t>
             </a:r>
             <a:endParaRPr lang="en-US" dirty="0"/>
           </a:p>
@@ -1235,7 +1235,7 @@
           <a:p>
             <a:r>
               <a:rPr lang="en-US" dirty="0"/>
-              <a:t>Notice the safe version is also the better prompt — more specific about what you actually want. Safer and more useful is the usual trade.</a:t>
+              <a:t>Notice the safe version is also the better prompt: more specific about what you actually want. Safer and more useful is the usual trade.</a:t>
             </a:r>
             <a:endParaRPr lang="en-US" dirty="0"/>
           </a:p>
@@ -1411,7 +1411,7 @@
           <a:p>
             <a:r>
               <a:rPr lang="en-US" dirty="0"/>
-              <a:t>Answers: A unsafe (initials + IEP contents). B safe. C unsafe — no name, but "the student who just moved here from Ukraine" identifies a child; fix: "a student who recently arrived from another country and is learning English." D safe — aggregate, no identities. Prompt C splits the room on purpose; resolve with the slide-12 test. 3 minutes, brisk.</a:t>
+              <a:t>Answers: A unsafe (initials + IEP contents). B safe. C unsafe: no name, but "the student who just moved here from Ukraine" identifies a child; fix: "a student who recently arrived from another country and is learning English." D safe: aggregate, no identities. Prompt C splits the room on purpose; resolve with the slide-12 test. 3 minutes, brisk.</a:t>
             </a:r>
             <a:endParaRPr lang="en-US" dirty="0"/>
           </a:p>
@@ -1499,7 +1499,7 @@
           <a:p>
             <a:r>
               <a:rPr lang="en-US" dirty="0"/>
-              <a:t>Two promises: not a sales pitch (skeptics are important here), not a scare session. Position: AI is a tool — it can take the robotic parts of the job, never the human parts. FOUNDER STORY (Katelyn) lands after this slide — see script.</a:t>
+              <a:t>Two promises: not a sales pitch (skeptics are important here), not a scare session. Position: AI is a tool: it can take the robotic parts of the job, never the human parts. FOUNDER STORY (Katelyn) lands after this slide; see script.</a:t>
             </a:r>
             <a:endParaRPr lang="en-US" dirty="0"/>
           </a:p>
@@ -1587,7 +1587,7 @@
           <a:p>
             <a:r>
               <a:rPr lang="en-US" dirty="0"/>
-              <a:t>Energy up — this is the moment the session exists for. Announce the tool by name. Pairs formed inside two minutes.</a:t>
+              <a:t>Energy up: this is the moment the session exists for. Announce the tool by name. Pairs formed inside two minutes.</a:t>
             </a:r>
             <a:endParaRPr lang="en-US" dirty="0"/>
           </a:p>
@@ -1675,7 +1675,7 @@
           <a:p>
             <a:r>
               <a:rPr lang="en-US" dirty="0"/>
-              <a:t>Circulate. Stuck pairs → option A, it works for every role. Deputize power users to float. LOCAL EXAMPLE (Adam): add an Option D from the shop — a real CTE prompt in your own words; see the script’s marked slot.</a:t>
+              <a:t>Circulate. Stuck pairs → option A, it works for every role. Deputize power users to float. LOCAL EXAMPLE (Adam): add an Option D from the shop, a real CTE prompt in your own words; see the script’s marked slot.</a:t>
             </a:r>
             <a:endParaRPr lang="en-US" dirty="0"/>
           </a:p>
@@ -1851,7 +1851,7 @@
           <a:p>
             <a:r>
               <a:rPr lang="en-US" dirty="0"/>
-              <a:t>If the room saw an AI mistake, spotlight it warmly — best possible outcome of the lab. Take 3–4 voices, a minute each.</a:t>
+              <a:t>If the room saw an AI mistake, spotlight it warmly; it’s the best possible outcome of the lab. Take 3–4 voices, a minute each.</a:t>
             </a:r>
             <a:endParaRPr lang="en-US" dirty="0"/>
           </a:p>
@@ -2027,7 +2027,7 @@
           <a:p>
             <a:r>
               <a:rPr lang="en-US" dirty="0"/>
-              <a:t>Nobody selling AI leads with these. Naming them is what earns the room’s trust. FOUNDER STORY (Adam — the shop, hands-on judgment) and YOUR TAKE (which risk worries you most) land here — see the script’s marked slots.</a:t>
+              <a:t>Nobody selling AI leads with these. Naming them is what earns the room’s trust. FOUNDER STORY (Adam: the shop, hands-on judgment) and YOUR TAKE (which risk worries you most) land here; see the script’s marked slots.</a:t>
             </a:r>
             <a:endParaRPr lang="en-US" dirty="0"/>
           </a:p>
@@ -2115,7 +2115,7 @@
           <a:p>
             <a:r>
               <a:rPr lang="en-US" dirty="0"/>
-              <a:t>Age facts: OpenAI terms — 13+ minimum, under-18 parental permission. Park student-cheating debates here explicitly: "That’s Kit 5 — today is about our use."</a:t>
+              <a:t>Age facts: OpenAI terms: 13+ minimum, under-18 parental permission. Park student-cheating debates here explicitly: "That’s Kit 5; today is about our use."</a:t>
             </a:r>
             <a:endParaRPr lang="en-US" dirty="0"/>
           </a:p>
@@ -2291,7 +2291,7 @@
           <a:p>
             <a:r>
               <a:rPr lang="en-US" dirty="0"/>
-              <a:t>Hold up the First 48 Hours sheet as you talk. Research basis for follow-through: Darling-Hammond et al. (2017) — sustained duration and active use are what make PD stick.</a:t>
+              <a:t>Hold up the First 48 Hours sheet as you talk. Research basis for follow-through: Darling-Hammond et al. (2017): sustained duration and active use are what make PD stick.</a:t>
             </a:r>
             <a:endParaRPr lang="en-US" dirty="0"/>
           </a:p>
@@ -2379,7 +2379,7 @@
           <a:p>
             <a:r>
               <a:rPr lang="en-US" dirty="0"/>
-              <a:t>Next up: Kit 2 — Prompting Basics: consistently useful results instead of occasionally lucky ones. Certificate language is exactly "Certificate of Completion" — check with your district whether it qualifies for local credit.</a:t>
+              <a:t>Next up is Kit 2, Prompting Basics: consistently useful results instead of occasionally lucky ones. Certificate language is exactly "Certificate of Completion"; check with your district whether it qualifies for local credit.</a:t>
             </a:r>
             <a:endParaRPr lang="en-US" dirty="0"/>
           </a:p>
@@ -2555,7 +2555,7 @@
           <a:p>
             <a:r>
               <a:rPr lang="en-US" dirty="0"/>
-              <a:t>Distribute exit tickets; collect at the door — they are the school’s PD documentation. Your worries steer what we do next. Thanks, everyone.</a:t>
+              <a:t>Distribute exit tickets; collect at the door; they are the school’s PD documentation. Your worries steer what we do next. Thanks, everyone.</a:t>
             </a:r>
             <a:endParaRPr lang="en-US" dirty="0"/>
           </a:p>
@@ -2643,7 +2643,7 @@
           <a:p>
             <a:r>
               <a:rPr lang="en-US" dirty="0"/>
-              <a:t>Research point (Darling-Hammond et al., Learning Policy Institute 2017): PD changes practice when it includes active learning and sustained follow-up — hence the lab and the 30-day plan. "This isn’t a one-and-done."</a:t>
+              <a:t>Research point (Darling-Hammond et al., Learning Policy Institute 2017): PD changes practice when it includes active learning and sustained follow-up; hence the lab and the 30-day plan. "This isn’t a one-and-done."</a:t>
             </a:r>
             <a:endParaRPr lang="en-US" dirty="0"/>
           </a:p>
@@ -2819,7 +2819,7 @@
           <a:p>
             <a:r>
               <a:rPr lang="en-US" dirty="0"/>
-              <a:t>Source: Linardon et al., JMIR Mental Health (2025) — GPT-4o literature-review test. This is called hallucination and it is a side effect of prediction, not a bug about to be fixed. If asked "why use it at all?": most classroom uses aren’t factual lookup — they’re drafting and reformatting, where you are the fact-checker by definition.</a:t>
+              <a:t>Source: Linardon et al., JMIR Mental Health (2025), the GPT-4o literature-review test. This is called hallucination and it is a side effect of prediction, not a bug about to be fixed. If asked "why use it at all?": most classroom uses aren’t factual lookup; they’re drafting and reformatting, where you are the fact-checker by definition.</a:t>
             </a:r>
             <a:endParaRPr lang="en-US" dirty="0"/>
           </a:p>
@@ -2907,7 +2907,7 @@
           <a:p>
             <a:r>
               <a:rPr lang="en-US" dirty="0"/>
-              <a:t>The intern only works because there is a professional in charge — that’s you. This five-word posture is the spine of the entire curriculum: AI drafts, the teacher decides.</a:t>
+              <a:t>The intern only works because there is a professional in charge. That’s you. This five-word posture is the spine of the entire curriculum: AI drafts, the teacher decides.</a:t>
             </a:r>
             <a:endParaRPr lang="en-US" dirty="0"/>
           </a:p>
@@ -2995,7 +2995,7 @@
           <a:p>
             <a:r>
               <a:rPr lang="en-US" dirty="0"/>
-              <a:t>These four categories cover most of what staff will actually do this year. The time-savings stat is Gallup–Walton 2025: weekly users save about 5.9 hours/week — roughly six weeks a year.</a:t>
+              <a:t>These four categories cover most of what staff will actually do this year. The time-savings stat is Gallup–Walton 2025: weekly users save about 5.9 hours/week, roughly six weeks a year.</a:t>
             </a:r>
             <a:endParaRPr lang="en-US" dirty="0"/>
           </a:p>
@@ -3083,7 +3083,7 @@
           <a:p>
             <a:r>
               <a:rPr lang="en-US" dirty="0"/>
-              <a:t>This is the session’s first explicit "human moment." Land it plainly and move on — the founder story on slide 25 will echo it.</a:t>
+              <a:t>This is the session’s first explicit "human moment." Land it plainly and move on; the founder story on slide 25 will echo it.</a:t>
             </a:r>
             <a:endParaRPr lang="en-US" dirty="0"/>
           </a:p>
@@ -3667,7 +3667,7 @@
                 <a:ea typeface="Inter" pitchFamily="34" charset="-122"/>
                 <a:cs typeface="Inter" pitchFamily="34" charset="-120"/>
               </a:rPr>
-              <a:t>A 45–60 minute working session for the whole staff — with 15 minutes hands-on.</a:t>
+              <a:t>A 45–60 minute working session for the whole staff, with 15 minutes hands-on.</a:t>
             </a:r>
             <a:endParaRPr lang="en-US" sz="1800" dirty="0"/>
           </a:p>
@@ -3706,7 +3706,7 @@
                 <a:ea typeface="Inter" pitchFamily="34" charset="-122"/>
                 <a:cs typeface="Inter" pitchFamily="34" charset="-120"/>
               </a:rPr>
-              <a:t>Built by Adam &amp; Katelyn Spinozzi — certified educators, 20+ combined years in the classroom</a:t>
+              <a:t>Built by Adam &amp; Katelyn Spinozzi · certified educators · 20+ combined years in the classroom</a:t>
             </a:r>
             <a:endParaRPr lang="en-US" sz="1200" dirty="0"/>
           </a:p>
@@ -5190,7 +5190,7 @@
                 <a:ea typeface="Inter" pitchFamily="34" charset="-122"/>
                 <a:cs typeface="Inter" pitchFamily="34" charset="-120"/>
               </a:rPr>
-              <a:t>The test: could anyone who knows our school figure out who this is?  If yes — it doesn’t go in.</a:t>
+              <a:t>The test: could anyone who knows our school figure out who this is?  If yes, it doesn’t go in.</a:t>
             </a:r>
             <a:endParaRPr lang="en-US" sz="1900" dirty="0"/>
           </a:p>
@@ -5521,7 +5521,7 @@
                 <a:ea typeface="Inter" pitchFamily="34" charset="-122"/>
                 <a:cs typeface="Inter" pitchFamily="34" charset="-120"/>
               </a:rPr>
-              <a:t>FERPA protects student education records — and schools answer for how record information is shared. A public AI tool is a third party with no agreement with our district. Where typed data goes depends on terms of service that change without asking us.</a:t>
+              <a:t>FERPA protects student education records, and schools answer for how record information is shared. A public AI tool is a third party with no agreement with our district. Where typed data goes depends on terms of service that change without asking us.</a:t>
             </a:r>
             <a:endParaRPr lang="en-US" sz="1700" dirty="0"/>
           </a:p>
@@ -5626,7 +5626,7 @@
                 <a:ea typeface="Inter" pitchFamily="34" charset="-122"/>
                 <a:cs typeface="Inter" pitchFamily="34" charset="-120"/>
               </a:rPr>
-              <a:t>An open chat box makes oversharing effortless — privacy researchers flag exactly this. And nobody in this room wants to be the example in the district’s cautionary email. One rule, followed always, means that’s never you.</a:t>
+              <a:t>An open chat box makes oversharing effortless; privacy researchers flag exactly this. And nobody in this room wants to be the example in the district’s cautionary email. One rule, followed always, means that’s never you.</a:t>
             </a:r>
             <a:endParaRPr lang="en-US" sz="1700" dirty="0"/>
           </a:p>
@@ -5665,7 +5665,7 @@
                 <a:ea typeface="Inter" pitchFamily="34" charset="-122"/>
                 <a:cs typeface="Inter" pitchFamily="34" charset="-120"/>
               </a:rPr>
-              <a:t>Educators sharing safe practice — not legal advice. District-specific questions go to the district office.</a:t>
+              <a:t>Educators sharing safe practice, not legal advice. District-specific questions go to the district office.</a:t>
             </a:r>
             <a:endParaRPr lang="en-US" sz="1300" dirty="0"/>
           </a:p>
@@ -5996,7 +5996,7 @@
                 <a:ea typeface="Inter" pitchFamily="34" charset="-122"/>
                 <a:cs typeface="Inter" pitchFamily="34" charset="-120"/>
               </a:rPr>
-              <a:t>Anything you signed up for yourself — free ChatGPT, Claude, Gemini, personal accounts.</a:t>
+              <a:t>Anything you signed up for yourself: free ChatGPT, Claude, Gemini, personal accounts.</a:t>
             </a:r>
             <a:endParaRPr lang="en-US" sz="1800" dirty="0"/>
           </a:p>
@@ -6798,7 +6798,7 @@
                 <a:ea typeface="Inter" pitchFamily="34" charset="-122"/>
                 <a:cs typeface="Inter" pitchFamily="34" charset="-120"/>
               </a:rPr>
-              <a:t>Safe swap #1 — the parent email</a:t>
+              <a:t>Safe swap #1: the parent email</a:t>
             </a:r>
             <a:endParaRPr lang="en-US" sz="3200" dirty="0"/>
           </a:p>
@@ -7234,7 +7234,7 @@
                 <a:ea typeface="Inter" pitchFamily="34" charset="-122"/>
                 <a:cs typeface="Inter" pitchFamily="34" charset="-120"/>
               </a:rPr>
-              <a:t>Safe swap #2 — differentiation</a:t>
+              <a:t>Safe swap #2: differentiation</a:t>
             </a:r>
             <a:endParaRPr lang="en-US" sz="3200" dirty="0"/>
           </a:p>
@@ -7483,7 +7483,7 @@
                 <a:ea typeface="Inter" pitchFamily="34" charset="-122"/>
                 <a:cs typeface="Inter" pitchFamily="34" charset="-120"/>
               </a:rPr>
-              <a:t>The AI never needed the diagnosis — it needed the reading level and the format.</a:t>
+              <a:t>The AI never needed the diagnosis; it needed the reading level and the format.</a:t>
             </a:r>
             <a:endParaRPr lang="en-US" sz="1800" dirty="0"/>
           </a:p>
@@ -7709,7 +7709,7 @@
                 <a:ea typeface="Inter" pitchFamily="34" charset="-122"/>
                 <a:cs typeface="Inter" pitchFamily="34" charset="-120"/>
               </a:rPr>
-              <a:t>De-identify like a pro — the 3 moves</a:t>
+              <a:t>De-identify like a pro: the 3 moves</a:t>
             </a:r>
             <a:endParaRPr lang="en-US" sz="3200" dirty="0"/>
           </a:p>
@@ -8442,7 +8442,7 @@
                 <a:ea typeface="Inter" pitchFamily="34" charset="-122"/>
                 <a:cs typeface="Inter" pitchFamily="34" charset="-120"/>
               </a:rPr>
-              <a:t>CALL IT OUT — SAFE OR UNSAFE?</a:t>
+              <a:t>CALL IT OUT: SAFE OR UNSAFE?</a:t>
             </a:r>
             <a:endParaRPr lang="en-US" sz="1200" dirty="0"/>
           </a:p>
@@ -8481,7 +8481,7 @@
                 <a:ea typeface="Inter" pitchFamily="34" charset="-122"/>
                 <a:cs typeface="Inter" pitchFamily="34" charset="-120"/>
               </a:rPr>
-              <a:t>You try — spot the problem</a:t>
+              <a:t>You try: spot the problem</a:t>
             </a:r>
             <a:endParaRPr lang="en-US" sz="3200" dirty="0"/>
           </a:p>
@@ -9235,7 +9235,7 @@
                 <a:ea typeface="Inter" pitchFamily="34" charset="-122"/>
                 <a:cs typeface="Inter" pitchFamily="34" charset="-120"/>
               </a:rPr>
-              <a:t>What today is — and isn’t</a:t>
+              <a:t>What today is (and isn’t)</a:t>
             </a:r>
             <a:endParaRPr lang="en-US" sz="3200" dirty="0"/>
           </a:p>
@@ -9905,7 +9905,7 @@
                 <a:ea typeface="Inter" pitchFamily="34" charset="-122"/>
                 <a:cs typeface="Inter" pitchFamily="34" charset="-120"/>
               </a:rPr>
-              <a:t>No student information — we practice like we play</a:t>
+              <a:t>No student information: we practice like we play</a:t>
             </a:r>
             <a:endParaRPr lang="en-US" sz="2100" dirty="0"/>
           </a:p>
@@ -10008,7 +10008,7 @@
                 <a:ea typeface="Inter" pitchFamily="34" charset="-122"/>
                 <a:cs typeface="Inter" pitchFamily="34" charset="-120"/>
               </a:rPr>
-              <a:t>Nothing has to be good — this is a sandbox</a:t>
+              <a:t>Nothing has to be good; this is a sandbox</a:t>
             </a:r>
             <a:endParaRPr lang="en-US" sz="2100" dirty="0"/>
           </a:p>
@@ -10111,7 +10111,7 @@
                 <a:ea typeface="Inter" pitchFamily="34" charset="-122"/>
                 <a:cs typeface="Inter" pitchFamily="34" charset="-120"/>
               </a:rPr>
-              <a:t>When it gives you something mediocre — don’t settle</a:t>
+              <a:t>When it gives you something mediocre, don’t settle</a:t>
             </a:r>
             <a:endParaRPr lang="en-US" sz="2100" dirty="0"/>
           </a:p>
@@ -10337,7 +10337,7 @@
                 <a:ea typeface="Inter" pitchFamily="34" charset="-122"/>
                 <a:cs typeface="Inter" pitchFamily="34" charset="-120"/>
               </a:rPr>
-              <a:t>Your first useful prompt — pick one</a:t>
+              <a:t>Your first useful prompt: pick one</a:t>
             </a:r>
             <a:endParaRPr lang="en-US" sz="3200" dirty="0"/>
           </a:p>
@@ -10844,7 +10844,7 @@
                 <a:ea typeface="Inter" pitchFamily="34" charset="-122"/>
                 <a:cs typeface="Inter" pitchFamily="34" charset="-120"/>
               </a:rPr>
-              <a:t>“Rewrite this paragraph at three different reading levels” — paste any paragraph you already have.</a:t>
+              <a:t>“Rewrite this paragraph at three different reading levels.” Then paste any paragraph you already have.</a:t>
             </a:r>
             <a:endParaRPr lang="en-US" sz="1650" dirty="0"/>
           </a:p>
@@ -11109,7 +11109,7 @@
                 <a:ea typeface="Inter" pitchFamily="34" charset="-122"/>
                 <a:cs typeface="Inter" pitchFamily="34" charset="-120"/>
               </a:rPr>
-              <a:t>Now push back — twice, minimum</a:t>
+              <a:t>Now push back: twice, minimum</a:t>
             </a:r>
             <a:endParaRPr lang="en-US" sz="3200" dirty="0"/>
           </a:p>
@@ -11741,7 +11741,7 @@
                 <a:ea typeface="Inter" pitchFamily="34" charset="-122"/>
                 <a:cs typeface="Inter" pitchFamily="34" charset="-120"/>
               </a:rPr>
-              <a:t>What was better than you expected — and what was worse?</a:t>
+              <a:t>What was better than you expected, and what was worse?</a:t>
             </a:r>
             <a:endParaRPr lang="en-US" sz="2300" dirty="0"/>
           </a:p>
@@ -11842,7 +11842,7 @@
                 <a:ea typeface="Inter" pitchFamily="34" charset="-122"/>
                 <a:cs typeface="Inter" pitchFamily="34" charset="-120"/>
               </a:rPr>
-              <a:t>the first draft is rarely the good draft — the value shows up when you push back. And everything you just made still needs your eyes: it’s fast, it’s fluent, and it’s unsigned until a professional signs it.</a:t>
+              <a:t>the first draft is rarely the good draft; the value shows up when you push back. And everything you just made still needs your eyes: it’s fast, it’s fluent, and it’s unsigned until a professional signs it.</a:t>
             </a:r>
             <a:endParaRPr lang="en-US" sz="1900" dirty="0"/>
           </a:p>
@@ -12177,7 +12177,7 @@
                 <a:ea typeface="Inter" pitchFamily="34" charset="-122"/>
                 <a:cs typeface="Inter" pitchFamily="34" charset="-120"/>
               </a:rPr>
-              <a:t>Not because it’s usually wrong — because sometimes it is, and your name is on it</a:t>
+              <a:t>Not because it’s usually wrong, but because sometimes it is, and your name is on it</a:t>
             </a:r>
             <a:endParaRPr lang="en-US" sz="2000" dirty="0"/>
           </a:p>
@@ -12445,7 +12445,7 @@
                 <a:ea typeface="Inter" pitchFamily="34" charset="-122"/>
                 <a:cs typeface="Inter" pitchFamily="34" charset="-120"/>
               </a:rPr>
-              <a:t>Honest limits — the risks are real</a:t>
+              <a:t>Honest limits: the risks are real</a:t>
             </a:r>
             <a:endParaRPr lang="en-US" sz="3200" dirty="0"/>
           </a:p>
@@ -12550,7 +12550,7 @@
                 <a:ea typeface="Inter" pitchFamily="34" charset="-122"/>
                 <a:cs typeface="Inter" pitchFamily="34" charset="-120"/>
               </a:rPr>
-              <a:t>If the tool writes everything, your writing muscle atrophies — students’ too</a:t>
+              <a:t>If the tool writes everything, your writing muscle atrophies; students’ too</a:t>
             </a:r>
             <a:endParaRPr lang="en-US" sz="1600" dirty="0"/>
           </a:p>
@@ -13068,7 +13068,7 @@
                 <a:ea typeface="Inter" pitchFamily="34" charset="-122"/>
                 <a:cs typeface="Inter" pitchFamily="34" charset="-120"/>
               </a:rPr>
-              <a:t>Major public chatbots require users to be 13+ — and minors need parent/guardian permission under the terms of service</a:t>
+              <a:t>Major public chatbots require users to be 13+, and minors need parent/guardian permission under the terms of service</a:t>
             </a:r>
             <a:endParaRPr lang="en-US" sz="2100" dirty="0"/>
           </a:p>
@@ -13089,7 +13089,7 @@
                 <a:ea typeface="Inter" pitchFamily="34" charset="-122"/>
                 <a:cs typeface="Inter" pitchFamily="34" charset="-120"/>
               </a:rPr>
-              <a:t>So student use is a real policy question — not a free-for-all, and not banned by default</a:t>
+              <a:t>So student use is a real policy question, not a free-for-all, and not banned by default</a:t>
             </a:r>
             <a:endParaRPr lang="en-US" sz="2100" dirty="0"/>
           </a:p>
@@ -13110,7 +13110,7 @@
                 <a:ea typeface="Inter" pitchFamily="34" charset="-122"/>
                 <a:cs typeface="Inter" pitchFamily="34" charset="-120"/>
               </a:rPr>
-              <a:t>It deserves its own session: that’s Kit 5 — AI &amp; Academic Integrity</a:t>
+              <a:t>It deserves its own session: that’s Kit 5, AI &amp; Academic Integrity</a:t>
             </a:r>
             <a:endParaRPr lang="en-US" sz="2100" dirty="0"/>
           </a:p>
@@ -13505,7 +13505,7 @@
                 <a:ea typeface="Inter" pitchFamily="34" charset="-122"/>
                 <a:cs typeface="Inter" pitchFamily="34" charset="-120"/>
               </a:rPr>
-              <a:t>No student personally identifiable information in public AI tools — ever</a:t>
+              <a:t>No student personally identifiable information in public AI tools. Ever</a:t>
             </a:r>
             <a:endParaRPr lang="en-US" sz="2300" dirty="0"/>
           </a:p>
@@ -13976,7 +13976,7 @@
                 <a:ea typeface="Inter" pitchFamily="34" charset="-122"/>
                 <a:cs typeface="Inter" pitchFamily="34" charset="-120"/>
               </a:rPr>
-              <a:t>Your first 48 hours — three small things</a:t>
+              <a:t>Your first 48 hours: three small things</a:t>
             </a:r>
             <a:endParaRPr lang="en-US" sz="3200" dirty="0"/>
           </a:p>
@@ -14120,7 +14120,7 @@
                 <a:ea typeface="Inter" pitchFamily="34" charset="-122"/>
                 <a:cs typeface="Inter" pitchFamily="34" charset="-120"/>
               </a:rPr>
-              <a:t>Something already on your to-do list — push back twice, review it, use it</a:t>
+              <a:t>Something already on your to-do list. Push back twice, review it, use it</a:t>
             </a:r>
             <a:endParaRPr lang="en-US" sz="1600" dirty="0"/>
           </a:p>
@@ -14264,7 +14264,7 @@
                 <a:ea typeface="Inter" pitchFamily="34" charset="-122"/>
                 <a:cs typeface="Inter" pitchFamily="34" charset="-120"/>
               </a:rPr>
-              <a:t>One real prompt, written unsafe then safe, on paper — the rep that builds the habit</a:t>
+              <a:t>One real prompt, written unsafe then safe, on paper; the rep that builds the habit</a:t>
             </a:r>
             <a:endParaRPr lang="en-US" sz="1600" dirty="0"/>
           </a:p>
@@ -14408,7 +14408,7 @@
                 <a:ea typeface="Inter" pitchFamily="34" charset="-122"/>
                 <a:cs typeface="Inter" pitchFamily="34" charset="-120"/>
               </a:rPr>
-              <a:t>One colleague, one specific thing — a win or a useful failure</a:t>
+              <a:t>One colleague, one specific thing: a win or a useful failure</a:t>
             </a:r>
             <a:endParaRPr lang="en-US" sz="1600" dirty="0"/>
           </a:p>
@@ -15281,7 +15281,7 @@
                 <a:ea typeface="Inter" pitchFamily="34" charset="-122"/>
                 <a:cs typeface="Inter" pitchFamily="34" charset="-120"/>
               </a:rPr>
-              <a:t>  Real documentation of real professional learning. Follow-ups run inside existing PLC time — nothing new to schedule.</a:t>
+              <a:t>  Real documentation of real professional learning. Follow-ups run inside existing PLC time; nothing new to schedule.</a:t>
             </a:r>
             <a:endParaRPr lang="en-US" sz="1800" dirty="0"/>
           </a:p>
@@ -15468,7 +15468,7 @@
                 <a:ea typeface="Inter" pitchFamily="34" charset="-122"/>
                 <a:cs typeface="Inter" pitchFamily="34" charset="-120"/>
               </a:rPr>
-              <a:t>WHY NOW — THREE NUMBERS</a:t>
+              <a:t>WHY NOW: THREE NUMBERS</a:t>
             </a:r>
             <a:endParaRPr lang="en-US" sz="1200" dirty="0"/>
           </a:p>
@@ -15640,7 +15640,7 @@
                 <a:ea typeface="Inter" pitchFamily="34" charset="-122"/>
                 <a:cs typeface="Inter" pitchFamily="34" charset="-120"/>
               </a:rPr>
-              <a:t>Teachers using AI for work —</a:t>
+              <a:t>Teachers using AI for work,</a:t>
             </a:r>
             <a:endParaRPr lang="en-US" sz="1600" dirty="0"/>
           </a:p>
@@ -16589,7 +16589,7 @@
                 <a:ea typeface="Inter" pitchFamily="34" charset="-122"/>
                 <a:cs typeface="Inter" pitchFamily="34" charset="-120"/>
               </a:rPr>
-              <a:t>Agenda — and one promise</a:t>
+              <a:t>Agenda, and one promise</a:t>
             </a:r>
             <a:endParaRPr lang="en-US" sz="3200" dirty="0"/>
           </a:p>
@@ -16823,7 +16823,7 @@
                 <a:ea typeface="Inter" pitchFamily="34" charset="-122"/>
                 <a:cs typeface="Inter" pitchFamily="34" charset="-120"/>
               </a:rPr>
-              <a:t>The One Hard Rule — student privacy</a:t>
+              <a:t>The One Hard Rule: student privacy</a:t>
             </a:r>
             <a:endParaRPr lang="en-US" sz="2000" dirty="0"/>
           </a:p>
@@ -16979,7 +16979,7 @@
                 <a:ea typeface="Inter" pitchFamily="34" charset="-122"/>
                 <a:cs typeface="Inter" pitchFamily="34" charset="-120"/>
               </a:rPr>
-              <a:t>Hands-on lab — you type, in pairs</a:t>
+              <a:t>Hands-on lab: you type, in pairs</a:t>
             </a:r>
             <a:endParaRPr lang="en-US" sz="2000" dirty="0"/>
           </a:p>
@@ -17240,7 +17240,7 @@
                 <a:ea typeface="Inter" pitchFamily="34" charset="-122"/>
                 <a:cs typeface="Inter" pitchFamily="34" charset="-120"/>
               </a:rPr>
-              <a:t>You will actually use an AI tool today — and leave with something for tomorrow morning.</a:t>
+              <a:t>You will actually use an AI tool today, and leave with something for tomorrow morning.</a:t>
             </a:r>
             <a:endParaRPr lang="en-US" sz="1400" dirty="0"/>
           </a:p>
@@ -17589,7 +17589,7 @@
                 <a:ea typeface="Inter" pitchFamily="34" charset="-122"/>
                 <a:cs typeface="Inter" pitchFamily="34" charset="-120"/>
               </a:rPr>
-              <a:t>Why the writing sounds so fluent — fluent is what it was trained to produce</a:t>
+              <a:t>Why the writing sounds so fluent: fluent is what it was trained to produce</a:t>
             </a:r>
             <a:endParaRPr lang="en-US" sz="2100" dirty="0"/>
           </a:p>
@@ -17610,7 +17610,7 @@
                 <a:ea typeface="Inter" pitchFamily="34" charset="-122"/>
                 <a:cs typeface="Inter" pitchFamily="34" charset="-120"/>
               </a:rPr>
-              <a:t>Why it can be smoothly, confidently wrong — it continues patterns; it doesn’t check facts</a:t>
+              <a:t>Why it can be smoothly, confidently wrong: it continues patterns instead of checking facts</a:t>
             </a:r>
             <a:endParaRPr lang="en-US" sz="2100" dirty="0"/>
           </a:p>
@@ -17962,7 +17962,7 @@
                 <a:ea typeface="Inter" pitchFamily="34" charset="-122"/>
                 <a:cs typeface="Inter" pitchFamily="34" charset="-120"/>
               </a:rPr>
-              <a:t>of citations produced by a leading AI model in a 2025 test were entirely fabricated — the papers did not exist</a:t>
+              <a:t>of citations produced by a leading AI model in a 2025 test were entirely fabricated. The papers did not exist</a:t>
             </a:r>
             <a:endParaRPr lang="en-US" sz="1700" dirty="0"/>
           </a:p>
@@ -18067,7 +18067,7 @@
                 <a:ea typeface="Inter" pitchFamily="34" charset="-122"/>
                 <a:cs typeface="Inter" pitchFamily="34" charset="-120"/>
               </a:rPr>
-              <a:t>of the real citations still contained errors — and every one of them looked perfect on the page</a:t>
+              <a:t>of the real citations still contained errors, and every one of them looked perfect on the page</a:t>
             </a:r>
             <a:endParaRPr lang="en-US" sz="1700" dirty="0"/>
           </a:p>
@@ -19141,7 +19141,7 @@
                 <a:ea typeface="Inter" pitchFamily="34" charset="-122"/>
                 <a:cs typeface="Inter" pitchFamily="34" charset="-120"/>
               </a:rPr>
-              <a:t>Teachers who use AI weekly report saving ~5.9 hours a week — the paperwork part of the job, not the teaching part. (Gallup &amp; Walton Family Foundation, 2025)</a:t>
+              <a:t>Teachers who use AI weekly report saving ~5.9 hours a week: the paperwork part of the job, not the teaching part. (Gallup &amp; Walton Family Foundation, 2025)</a:t>
             </a:r>
             <a:endParaRPr lang="en-US" sz="1600" dirty="0"/>
           </a:p>
@@ -19367,7 +19367,7 @@
                 <a:ea typeface="Inter" pitchFamily="34" charset="-122"/>
                 <a:cs typeface="Inter" pitchFamily="34" charset="-120"/>
               </a:rPr>
-              <a:t>What it can’t do — at any price</a:t>
+              <a:t>What it can’t do, at any price</a:t>
             </a:r>
             <a:endParaRPr lang="en-US" sz="3200" dirty="0"/>
           </a:p>
@@ -19410,7 +19410,7 @@
                 <a:ea typeface="Inter" pitchFamily="34" charset="-122"/>
                 <a:cs typeface="Inter" pitchFamily="34" charset="-120"/>
               </a:rPr>
-              <a:t>Know your students — that this class shuts down after lunch, that this kid needs a win today</a:t>
+              <a:t>Know your students: that this class shuts down after lunch, that this kid needs a win today</a:t>
             </a:r>
             <a:endParaRPr lang="en-US" sz="2100" dirty="0"/>
           </a:p>
@@ -19431,7 +19431,7 @@
                 <a:ea typeface="Inter" pitchFamily="34" charset="-122"/>
                 <a:cs typeface="Inter" pitchFamily="34" charset="-120"/>
               </a:rPr>
-              <a:t>Verify its own facts — that’s you</a:t>
+              <a:t>Verify its own facts (that’s you)</a:t>
             </a:r>
             <a:endParaRPr lang="en-US" sz="2100" dirty="0"/>
           </a:p>
@@ -19452,7 +19452,7 @@
                 <a:ea typeface="Inter" pitchFamily="34" charset="-122"/>
                 <a:cs typeface="Inter" pitchFamily="34" charset="-120"/>
               </a:rPr>
-              <a:t>Care — it produces text, not judgment, and not relationships</a:t>
+              <a:t>Care: it produces text, not judgment, and not relationships</a:t>
             </a:r>
             <a:endParaRPr lang="en-US" sz="2100" dirty="0"/>
           </a:p>
@@ -19518,7 +19518,7 @@
                 <a:ea typeface="Inter" pitchFamily="34" charset="-122"/>
                 <a:cs typeface="Inter" pitchFamily="34" charset="-120"/>
               </a:rPr>
-              <a:t>Everything on this slide is your job on purpose. The tool buys back time FOR this list — it never takes this list away.</a:t>
+              <a:t>Everything on this slide is your job on purpose. The tool buys back time FOR this list; it never takes this list away.</a:t>
             </a:r>
             <a:endParaRPr lang="en-US" sz="2100" dirty="0"/>
           </a:p>

</xml_diff>

<commit_message>
Owner edits: founder stories filled in; breathing room brand-wide
- Script slide 2: Katelyn's preschool graduation-speech story (read-aloud)
- Script slide 25: Adam's table-saw kickback story + the authors' shared
  take (over-reliance is the biggest risk)
- Lab Option D: Adam's miter-saw safety-check prompt, in script and deck
  slide 21; deck notes updated on slides 2, 21, 25
- brand.css: ~0.5in clear space under the band on every page (gap lives in
  the repeating header), more space above the footer; prep guide flexes to
  4 pages rather than compress
- PROVENANCE logs the founder inputs; DECISIONS records spacing as
  brand-wide for the Part II site and portals

Co-Authored-By: Claude Opus 5 <noreply@anthropic.com>
Claude-Session: https://claude.ai/code/session_01UrWWr3vbRywthE5aNZWdnr
</commit_message>
<xml_diff>
--- a/kits/kit01/Kit01_PresentationDeck.pptx
+++ b/kits/kit01/Kit01_PresentationDeck.pptx
@@ -1499,7 +1499,7 @@
           <a:p>
             <a:r>
               <a:rPr lang="en-US" dirty="0"/>
-              <a:t>Two promises: not a sales pitch (skeptics are important here), not a scare session. Position: AI is a tool: it can take the robotic parts of the job, never the human parts. FOUNDER STORY (Katelyn) lands after this slide; see script.</a:t>
+              <a:t>Two promises: not a sales pitch (skeptics are important here), not a scare session. Position: AI is a tool: it can take the robotic parts of the job, never the human parts. Then read Katelyn Spinozzi’s graduation-speech story from the script: ChatGPT nailed the length and timing but wasn’t age-appropriate or personal; she rewrote it with her kids in it. AI drafts, the teacher decides.</a:t>
             </a:r>
             <a:endParaRPr lang="en-US" dirty="0"/>
           </a:p>
@@ -1675,7 +1675,7 @@
           <a:p>
             <a:r>
               <a:rPr lang="en-US" dirty="0"/>
-              <a:t>Circulate. Stuck pairs → option A, it works for every role. Deputize power users to float. LOCAL EXAMPLE (Adam): add an Option D from the shop, a real CTE prompt in your own words; see the script’s marked slot.</a:t>
+              <a:t>Circulate. Stuck pairs → option A, it works for every role. Deputize power users to float. Option D is Adam Spinozzi’s own prompt from his carpentry room; say so, and invite electives staff to swap in their station or lab.</a:t>
             </a:r>
             <a:endParaRPr lang="en-US" dirty="0"/>
           </a:p>
@@ -2027,7 +2027,7 @@
           <a:p>
             <a:r>
               <a:rPr lang="en-US" dirty="0"/>
-              <a:t>Nobody selling AI leads with these. Naming them is what earns the room’s trust. FOUNDER STORY (Adam: the shop, hands-on judgment) and YOUR TAKE (which risk worries you most) land here; see the script’s marked slots.</a:t>
+              <a:t>Nobody selling AI leads with these. Naming them is what earns the room’s trust. Then read the two author passages from the script: Adam Spinozzi’s table-saw story (his student caught a kickback setup by eye, from experience, not from AI) and the authors’ shared take: over-reliance is the biggest risk; students must identify the problem and the tools before AI helps.</a:t>
             </a:r>
             <a:endParaRPr lang="en-US" dirty="0"/>
           </a:p>
@@ -10351,12 +10351,12 @@
         </p:nvSpPr>
         <p:spPr>
           <a:xfrm>
-            <a:off x="640080" y="1417320"/>
-            <a:ext cx="10972800" cy="1234440"/>
+            <a:off x="640080" y="1298448"/>
+            <a:ext cx="10972800" cy="987552"/>
           </a:xfrm>
           <a:prstGeom prst="roundRect">
             <a:avLst>
-              <a:gd name="adj" fmla="val 6667"/>
+              <a:gd name="adj" fmla="val 8333"/>
             </a:avLst>
           </a:prstGeom>
           <a:solidFill>
@@ -10378,8 +10378,8 @@
         </p:nvSpPr>
         <p:spPr>
           <a:xfrm>
-            <a:off x="914400" y="1719072"/>
-            <a:ext cx="640080" cy="640080"/>
+            <a:off x="914400" y="1490472"/>
+            <a:ext cx="603504" cy="603504"/>
           </a:xfrm>
           <a:prstGeom prst="ellipse">
             <a:avLst/>
@@ -10403,8 +10403,8 @@
         </p:nvSpPr>
         <p:spPr>
           <a:xfrm>
-            <a:off x="914400" y="1719072"/>
-            <a:ext cx="640080" cy="640080"/>
+            <a:off x="914400" y="1490472"/>
+            <a:ext cx="603504" cy="603504"/>
           </a:xfrm>
           <a:prstGeom prst="rect">
             <a:avLst/>
@@ -10420,7 +10420,7 @@
               <a:buNone/>
             </a:pPr>
             <a:r>
-              <a:rPr lang="en-US" sz="2200" b="1" dirty="0">
+              <a:rPr lang="en-US" sz="2100" b="1" dirty="0">
                 <a:solidFill>
                   <a:srgbClr val="FFFFFF"/>
                 </a:solidFill>
@@ -10430,7 +10430,7 @@
               </a:rPr>
               <a:t>A</a:t>
             </a:r>
-            <a:endParaRPr lang="en-US" sz="2200" dirty="0"/>
+            <a:endParaRPr lang="en-US" sz="2100" dirty="0"/>
           </a:p>
         </p:txBody>
       </p:sp>
@@ -10442,24 +10442,24 @@
         </p:nvSpPr>
         <p:spPr>
           <a:xfrm>
-            <a:off x="1783080" y="1545336"/>
-            <a:ext cx="2743200" cy="292608"/>
-          </a:xfrm>
-          <a:prstGeom prst="rect">
-            <a:avLst/>
-          </a:prstGeom>
-          <a:noFill/>
-          <a:ln/>
-        </p:spPr>
-        <p:txBody>
-          <a:bodyPr wrap="square" lIns="0" tIns="0" rIns="0" bIns="0" rtlCol="0" anchor="ctr"/>
-          <a:lstStyle/>
-          <a:p>
-            <a:pPr indent="0" marL="0">
-              <a:buNone/>
-            </a:pPr>
-            <a:r>
-              <a:rPr lang="en-US" sz="1200" b="1" spc="150" kern="0" dirty="0">
+            <a:off x="1783080" y="1389888"/>
+            <a:ext cx="3657600" cy="274320"/>
+          </a:xfrm>
+          <a:prstGeom prst="rect">
+            <a:avLst/>
+          </a:prstGeom>
+          <a:noFill/>
+          <a:ln/>
+        </p:spPr>
+        <p:txBody>
+          <a:bodyPr wrap="square" lIns="0" tIns="0" rIns="0" bIns="0" rtlCol="0" anchor="ctr"/>
+          <a:lstStyle/>
+          <a:p>
+            <a:pPr indent="0" marL="0">
+              <a:buNone/>
+            </a:pPr>
+            <a:r>
+              <a:rPr lang="en-US" sz="1100" b="1" spc="150" kern="0" dirty="0">
                 <a:solidFill>
                   <a:srgbClr val="2A9D8F"/>
                 </a:solidFill>
@@ -10469,7 +10469,7 @@
               </a:rPr>
               <a:t>FAMILIES</a:t>
             </a:r>
-            <a:endParaRPr lang="en-US" sz="1200" dirty="0"/>
+            <a:endParaRPr lang="en-US" sz="1100" dirty="0"/>
           </a:p>
         </p:txBody>
       </p:sp>
@@ -10481,8 +10481,8 @@
         </p:nvSpPr>
         <p:spPr>
           <a:xfrm>
-            <a:off x="1783080" y="1828800"/>
-            <a:ext cx="9509760" cy="777240"/>
+            <a:off x="1783080" y="1645920"/>
+            <a:ext cx="9509760" cy="603504"/>
           </a:xfrm>
           <a:prstGeom prst="rect">
             <a:avLst/>
@@ -10498,7 +10498,7 @@
               <a:buNone/>
             </a:pPr>
             <a:r>
-              <a:rPr lang="en-US" sz="1650" dirty="0">
+              <a:rPr lang="en-US" sz="1450" dirty="0">
                 <a:solidFill>
                   <a:srgbClr val="1B1F24"/>
                 </a:solidFill>
@@ -10508,7 +10508,7 @@
               </a:rPr>
               <a:t>“Write a warm, professional newsletter blurb for families about [any upcoming school event], under 120 words.”</a:t>
             </a:r>
-            <a:endParaRPr lang="en-US" sz="1650" dirty="0"/>
+            <a:endParaRPr lang="en-US" sz="1450" dirty="0"/>
           </a:p>
         </p:txBody>
       </p:sp>
@@ -10520,12 +10520,12 @@
         </p:nvSpPr>
         <p:spPr>
           <a:xfrm>
-            <a:off x="640080" y="2834640"/>
-            <a:ext cx="10972800" cy="1234440"/>
+            <a:off x="640080" y="2414016"/>
+            <a:ext cx="10972800" cy="987552"/>
           </a:xfrm>
           <a:prstGeom prst="roundRect">
             <a:avLst>
-              <a:gd name="adj" fmla="val 6667"/>
+              <a:gd name="adj" fmla="val 8333"/>
             </a:avLst>
           </a:prstGeom>
           <a:solidFill>
@@ -10547,8 +10547,8 @@
         </p:nvSpPr>
         <p:spPr>
           <a:xfrm>
-            <a:off x="914400" y="3136392"/>
-            <a:ext cx="640080" cy="640080"/>
+            <a:off x="914400" y="2606040"/>
+            <a:ext cx="603504" cy="603504"/>
           </a:xfrm>
           <a:prstGeom prst="ellipse">
             <a:avLst/>
@@ -10572,8 +10572,8 @@
         </p:nvSpPr>
         <p:spPr>
           <a:xfrm>
-            <a:off x="914400" y="3136392"/>
-            <a:ext cx="640080" cy="640080"/>
+            <a:off x="914400" y="2606040"/>
+            <a:ext cx="603504" cy="603504"/>
           </a:xfrm>
           <a:prstGeom prst="rect">
             <a:avLst/>
@@ -10589,7 +10589,7 @@
               <a:buNone/>
             </a:pPr>
             <a:r>
-              <a:rPr lang="en-US" sz="2200" b="1" dirty="0">
+              <a:rPr lang="en-US" sz="2100" b="1" dirty="0">
                 <a:solidFill>
                   <a:srgbClr val="FFFFFF"/>
                 </a:solidFill>
@@ -10599,7 +10599,7 @@
               </a:rPr>
               <a:t>B</a:t>
             </a:r>
-            <a:endParaRPr lang="en-US" sz="2200" dirty="0"/>
+            <a:endParaRPr lang="en-US" sz="2100" dirty="0"/>
           </a:p>
         </p:txBody>
       </p:sp>
@@ -10611,24 +10611,24 @@
         </p:nvSpPr>
         <p:spPr>
           <a:xfrm>
-            <a:off x="1783080" y="2962656"/>
-            <a:ext cx="2743200" cy="292608"/>
-          </a:xfrm>
-          <a:prstGeom prst="rect">
-            <a:avLst/>
-          </a:prstGeom>
-          <a:noFill/>
-          <a:ln/>
-        </p:spPr>
-        <p:txBody>
-          <a:bodyPr wrap="square" lIns="0" tIns="0" rIns="0" bIns="0" rtlCol="0" anchor="ctr"/>
-          <a:lstStyle/>
-          <a:p>
-            <a:pPr indent="0" marL="0">
-              <a:buNone/>
-            </a:pPr>
-            <a:r>
-              <a:rPr lang="en-US" sz="1200" b="1" spc="150" kern="0" dirty="0">
+            <a:off x="1783080" y="2505456"/>
+            <a:ext cx="3657600" cy="274320"/>
+          </a:xfrm>
+          <a:prstGeom prst="rect">
+            <a:avLst/>
+          </a:prstGeom>
+          <a:noFill/>
+          <a:ln/>
+        </p:spPr>
+        <p:txBody>
+          <a:bodyPr wrap="square" lIns="0" tIns="0" rIns="0" bIns="0" rtlCol="0" anchor="ctr"/>
+          <a:lstStyle/>
+          <a:p>
+            <a:pPr indent="0" marL="0">
+              <a:buNone/>
+            </a:pPr>
+            <a:r>
+              <a:rPr lang="en-US" sz="1100" b="1" spc="150" kern="0" dirty="0">
                 <a:solidFill>
                   <a:srgbClr val="2A9D8F"/>
                 </a:solidFill>
@@ -10638,7 +10638,7 @@
               </a:rPr>
               <a:t>ASSESSMENT</a:t>
             </a:r>
-            <a:endParaRPr lang="en-US" sz="1200" dirty="0"/>
+            <a:endParaRPr lang="en-US" sz="1100" dirty="0"/>
           </a:p>
         </p:txBody>
       </p:sp>
@@ -10650,8 +10650,8 @@
         </p:nvSpPr>
         <p:spPr>
           <a:xfrm>
-            <a:off x="1783080" y="3246120"/>
-            <a:ext cx="9509760" cy="777240"/>
+            <a:off x="1783080" y="2761488"/>
+            <a:ext cx="9509760" cy="603504"/>
           </a:xfrm>
           <a:prstGeom prst="rect">
             <a:avLst/>
@@ -10667,7 +10667,7 @@
               <a:buNone/>
             </a:pPr>
             <a:r>
-              <a:rPr lang="en-US" sz="1650" dirty="0">
+              <a:rPr lang="en-US" sz="1450" dirty="0">
                 <a:solidFill>
                   <a:srgbClr val="1B1F24"/>
                 </a:solidFill>
@@ -10677,7 +10677,7 @@
               </a:rPr>
               <a:t>“Create a five-question review quiz on [any topic you teach], mixed difficulty, with an answer key.”</a:t>
             </a:r>
-            <a:endParaRPr lang="en-US" sz="1650" dirty="0"/>
+            <a:endParaRPr lang="en-US" sz="1450" dirty="0"/>
           </a:p>
         </p:txBody>
       </p:sp>
@@ -10689,12 +10689,12 @@
         </p:nvSpPr>
         <p:spPr>
           <a:xfrm>
-            <a:off x="640080" y="4251960"/>
-            <a:ext cx="10972800" cy="1234440"/>
+            <a:off x="640080" y="3529584"/>
+            <a:ext cx="10972800" cy="987552"/>
           </a:xfrm>
           <a:prstGeom prst="roundRect">
             <a:avLst>
-              <a:gd name="adj" fmla="val 6667"/>
+              <a:gd name="adj" fmla="val 8333"/>
             </a:avLst>
           </a:prstGeom>
           <a:solidFill>
@@ -10716,8 +10716,8 @@
         </p:nvSpPr>
         <p:spPr>
           <a:xfrm>
-            <a:off x="914400" y="4553712"/>
-            <a:ext cx="640080" cy="640080"/>
+            <a:off x="914400" y="3721608"/>
+            <a:ext cx="603504" cy="603504"/>
           </a:xfrm>
           <a:prstGeom prst="ellipse">
             <a:avLst/>
@@ -10741,8 +10741,8 @@
         </p:nvSpPr>
         <p:spPr>
           <a:xfrm>
-            <a:off x="914400" y="4553712"/>
-            <a:ext cx="640080" cy="640080"/>
+            <a:off x="914400" y="3721608"/>
+            <a:ext cx="603504" cy="603504"/>
           </a:xfrm>
           <a:prstGeom prst="rect">
             <a:avLst/>
@@ -10758,7 +10758,7 @@
               <a:buNone/>
             </a:pPr>
             <a:r>
-              <a:rPr lang="en-US" sz="2200" b="1" dirty="0">
+              <a:rPr lang="en-US" sz="2100" b="1" dirty="0">
                 <a:solidFill>
                   <a:srgbClr val="FFFFFF"/>
                 </a:solidFill>
@@ -10768,7 +10768,7 @@
               </a:rPr>
               <a:t>C</a:t>
             </a:r>
-            <a:endParaRPr lang="en-US" sz="2200" dirty="0"/>
+            <a:endParaRPr lang="en-US" sz="2100" dirty="0"/>
           </a:p>
         </p:txBody>
       </p:sp>
@@ -10780,24 +10780,24 @@
         </p:nvSpPr>
         <p:spPr>
           <a:xfrm>
-            <a:off x="1783080" y="4379976"/>
-            <a:ext cx="2743200" cy="292608"/>
-          </a:xfrm>
-          <a:prstGeom prst="rect">
-            <a:avLst/>
-          </a:prstGeom>
-          <a:noFill/>
-          <a:ln/>
-        </p:spPr>
-        <p:txBody>
-          <a:bodyPr wrap="square" lIns="0" tIns="0" rIns="0" bIns="0" rtlCol="0" anchor="ctr"/>
-          <a:lstStyle/>
-          <a:p>
-            <a:pPr indent="0" marL="0">
-              <a:buNone/>
-            </a:pPr>
-            <a:r>
-              <a:rPr lang="en-US" sz="1200" b="1" spc="150" kern="0" dirty="0">
+            <a:off x="1783080" y="3621024"/>
+            <a:ext cx="3657600" cy="274320"/>
+          </a:xfrm>
+          <a:prstGeom prst="rect">
+            <a:avLst/>
+          </a:prstGeom>
+          <a:noFill/>
+          <a:ln/>
+        </p:spPr>
+        <p:txBody>
+          <a:bodyPr wrap="square" lIns="0" tIns="0" rIns="0" bIns="0" rtlCol="0" anchor="ctr"/>
+          <a:lstStyle/>
+          <a:p>
+            <a:pPr indent="0" marL="0">
+              <a:buNone/>
+            </a:pPr>
+            <a:r>
+              <a:rPr lang="en-US" sz="1100" b="1" spc="150" kern="0" dirty="0">
                 <a:solidFill>
                   <a:srgbClr val="2A9D8F"/>
                 </a:solidFill>
@@ -10807,7 +10807,7 @@
               </a:rPr>
               <a:t>DIFFERENTIATION</a:t>
             </a:r>
-            <a:endParaRPr lang="en-US" sz="1200" dirty="0"/>
+            <a:endParaRPr lang="en-US" sz="1100" dirty="0"/>
           </a:p>
         </p:txBody>
       </p:sp>
@@ -10819,8 +10819,8 @@
         </p:nvSpPr>
         <p:spPr>
           <a:xfrm>
-            <a:off x="1783080" y="4663440"/>
-            <a:ext cx="9509760" cy="777240"/>
+            <a:off x="1783080" y="3877056"/>
+            <a:ext cx="9509760" cy="603504"/>
           </a:xfrm>
           <a:prstGeom prst="rect">
             <a:avLst/>
@@ -10836,7 +10836,7 @@
               <a:buNone/>
             </a:pPr>
             <a:r>
-              <a:rPr lang="en-US" sz="1650" dirty="0">
+              <a:rPr lang="en-US" sz="1450" dirty="0">
                 <a:solidFill>
                   <a:srgbClr val="1B1F24"/>
                 </a:solidFill>
@@ -10846,19 +10846,188 @@
               </a:rPr>
               <a:t>“Rewrite this paragraph at three different reading levels.” Then paste any paragraph you already have.</a:t>
             </a:r>
-            <a:endParaRPr lang="en-US" sz="1650" dirty="0"/>
-          </a:p>
-        </p:txBody>
-      </p:sp>
-      <p:sp>
-        <p:nvSpPr>
-          <p:cNvPr id="22" name="Text 19"/>
-          <p:cNvSpPr/>
-          <p:nvPr/>
-        </p:nvSpPr>
-        <p:spPr>
-          <a:xfrm>
-            <a:off x="640080" y="5760720"/>
+            <a:endParaRPr lang="en-US" sz="1450" dirty="0"/>
+          </a:p>
+        </p:txBody>
+      </p:sp>
+      <p:sp>
+        <p:nvSpPr>
+          <p:cNvPr id="22" name="Shape 19"/>
+          <p:cNvSpPr/>
+          <p:nvPr/>
+        </p:nvSpPr>
+        <p:spPr>
+          <a:xfrm>
+            <a:off x="640080" y="4645152"/>
+            <a:ext cx="10972800" cy="987552"/>
+          </a:xfrm>
+          <a:prstGeom prst="roundRect">
+            <a:avLst>
+              <a:gd name="adj" fmla="val 8333"/>
+            </a:avLst>
+          </a:prstGeom>
+          <a:solidFill>
+            <a:srgbClr val="F7F5F0"/>
+          </a:solidFill>
+          <a:ln w="12700">
+            <a:solidFill>
+              <a:srgbClr val="F7F5F0"/>
+            </a:solidFill>
+            <a:prstDash val="solid"/>
+          </a:ln>
+        </p:spPr>
+      </p:sp>
+      <p:sp>
+        <p:nvSpPr>
+          <p:cNvPr id="23" name="Shape 20"/>
+          <p:cNvSpPr/>
+          <p:nvPr/>
+        </p:nvSpPr>
+        <p:spPr>
+          <a:xfrm>
+            <a:off x="914400" y="4837176"/>
+            <a:ext cx="603504" cy="603504"/>
+          </a:xfrm>
+          <a:prstGeom prst="ellipse">
+            <a:avLst/>
+          </a:prstGeom>
+          <a:solidFill>
+            <a:srgbClr val="2A9D8F"/>
+          </a:solidFill>
+          <a:ln w="12700">
+            <a:solidFill>
+              <a:srgbClr val="2A9D8F"/>
+            </a:solidFill>
+            <a:prstDash val="solid"/>
+          </a:ln>
+        </p:spPr>
+      </p:sp>
+      <p:sp>
+        <p:nvSpPr>
+          <p:cNvPr id="24" name="Text 21"/>
+          <p:cNvSpPr/>
+          <p:nvPr/>
+        </p:nvSpPr>
+        <p:spPr>
+          <a:xfrm>
+            <a:off x="914400" y="4837176"/>
+            <a:ext cx="603504" cy="603504"/>
+          </a:xfrm>
+          <a:prstGeom prst="rect">
+            <a:avLst/>
+          </a:prstGeom>
+          <a:noFill/>
+          <a:ln/>
+        </p:spPr>
+        <p:txBody>
+          <a:bodyPr wrap="square" lIns="0" tIns="0" rIns="0" bIns="0" rtlCol="0" anchor="ctr"/>
+          <a:lstStyle/>
+          <a:p>
+            <a:pPr algn="ctr" indent="0" marL="0">
+              <a:buNone/>
+            </a:pPr>
+            <a:r>
+              <a:rPr lang="en-US" sz="2100" b="1" dirty="0">
+                <a:solidFill>
+                  <a:srgbClr val="FFFFFF"/>
+                </a:solidFill>
+                <a:latin typeface="Inter" pitchFamily="34" charset="0"/>
+                <a:ea typeface="Inter" pitchFamily="34" charset="-122"/>
+                <a:cs typeface="Inter" pitchFamily="34" charset="-120"/>
+              </a:rPr>
+              <a:t>D</a:t>
+            </a:r>
+            <a:endParaRPr lang="en-US" sz="2100" dirty="0"/>
+          </a:p>
+        </p:txBody>
+      </p:sp>
+      <p:sp>
+        <p:nvSpPr>
+          <p:cNvPr id="25" name="Text 22"/>
+          <p:cNvSpPr/>
+          <p:nvPr/>
+        </p:nvSpPr>
+        <p:spPr>
+          <a:xfrm>
+            <a:off x="1783080" y="4736592"/>
+            <a:ext cx="3657600" cy="274320"/>
+          </a:xfrm>
+          <a:prstGeom prst="rect">
+            <a:avLst/>
+          </a:prstGeom>
+          <a:noFill/>
+          <a:ln/>
+        </p:spPr>
+        <p:txBody>
+          <a:bodyPr wrap="square" lIns="0" tIns="0" rIns="0" bIns="0" rtlCol="0" anchor="ctr"/>
+          <a:lstStyle/>
+          <a:p>
+            <a:pPr indent="0" marL="0">
+              <a:buNone/>
+            </a:pPr>
+            <a:r>
+              <a:rPr lang="en-US" sz="1100" b="1" spc="150" kern="0" dirty="0">
+                <a:solidFill>
+                  <a:srgbClr val="2A9D8F"/>
+                </a:solidFill>
+                <a:latin typeface="Inter" pitchFamily="34" charset="0"/>
+                <a:ea typeface="Inter" pitchFamily="34" charset="-122"/>
+                <a:cs typeface="Inter" pitchFamily="34" charset="-120"/>
+              </a:rPr>
+              <a:t>CTE &amp; ELECTIVES</a:t>
+            </a:r>
+            <a:endParaRPr lang="en-US" sz="1100" dirty="0"/>
+          </a:p>
+        </p:txBody>
+      </p:sp>
+      <p:sp>
+        <p:nvSpPr>
+          <p:cNvPr id="26" name="Text 23"/>
+          <p:cNvSpPr/>
+          <p:nvPr/>
+        </p:nvSpPr>
+        <p:spPr>
+          <a:xfrm>
+            <a:off x="1783080" y="4992624"/>
+            <a:ext cx="9509760" cy="603504"/>
+          </a:xfrm>
+          <a:prstGeom prst="rect">
+            <a:avLst/>
+          </a:prstGeom>
+          <a:noFill/>
+          <a:ln/>
+        </p:spPr>
+        <p:txBody>
+          <a:bodyPr wrap="square" lIns="0" tIns="0" rIns="0" bIns="0" rtlCol="0" anchor="t"/>
+          <a:lstStyle/>
+          <a:p>
+            <a:pPr indent="0" marL="0">
+              <a:buNone/>
+            </a:pPr>
+            <a:r>
+              <a:rPr lang="en-US" sz="1450" dirty="0">
+                <a:solidFill>
+                  <a:srgbClr val="1B1F24"/>
+                </a:solidFill>
+                <a:latin typeface="Inter" pitchFamily="34" charset="0"/>
+                <a:ea typeface="Inter" pitchFamily="34" charset="-122"/>
+                <a:cs typeface="Inter" pitchFamily="34" charset="-120"/>
+              </a:rPr>
+              <a:t>“Create a five-question tool safety check for the miter saw station, mixed question formats, with an answer key.” Swap in any station, lab, kitchen, or instrument.</a:t>
+            </a:r>
+            <a:endParaRPr lang="en-US" sz="1450" dirty="0"/>
+          </a:p>
+        </p:txBody>
+      </p:sp>
+      <p:sp>
+        <p:nvSpPr>
+          <p:cNvPr id="27" name="Text 24"/>
+          <p:cNvSpPr/>
+          <p:nvPr/>
+        </p:nvSpPr>
+        <p:spPr>
+          <a:xfrm>
+            <a:off x="640080" y="5806440"/>
             <a:ext cx="10972800" cy="411480"/>
           </a:xfrm>
           <a:prstGeom prst="rect">
@@ -10875,7 +11044,7 @@
               <a:buNone/>
             </a:pPr>
             <a:r>
-              <a:rPr lang="en-US" sz="1700" i="1" dirty="0">
+              <a:rPr lang="en-US" sz="1600" i="1" dirty="0">
                 <a:solidFill>
                   <a:srgbClr val="5B6B7A"/>
                 </a:solidFill>
@@ -10885,7 +11054,7 @@
               </a:rPr>
               <a:t>Pick whichever is closest to your real job. Type it. Read what comes back.</a:t>
             </a:r>
-            <a:endParaRPr lang="en-US" sz="1700" dirty="0"/>
+            <a:endParaRPr lang="en-US" sz="1600" dirty="0"/>
           </a:p>
         </p:txBody>
       </p:sp>

</xml_diff>

<commit_message>
Owner corrections to read-alouds: first names only, Kate's story clarified
- Kate's passage now states the personalization happened in her own
  rewrite, outside the tool (no student info ever entered AI)
- Adam referred to as a carpentry teacher; last names removed from all
  read-aloud passages and deck notes (formal credit lines unchanged)
- Provenance updated

Co-Authored-By: Claude Opus 5 <noreply@anthropic.com>
Claude-Session: https://claude.ai/code/session_01UrWWr3vbRywthE5aNZWdnr
</commit_message>
<xml_diff>
--- a/kits/kit01/Kit01_PresentationDeck.pptx
+++ b/kits/kit01/Kit01_PresentationDeck.pptx
@@ -1499,7 +1499,7 @@
           <a:p>
             <a:r>
               <a:rPr lang="en-US" dirty="0"/>
-              <a:t>Two promises: not a sales pitch (skeptics are important here), not a scare session. Position: AI is a tool: it can take the robotic parts of the job, never the human parts. Then read Katelyn Spinozzi’s graduation-speech story from the script: ChatGPT nailed the length and timing but wasn’t age-appropriate or personal; she rewrote it with her kids in it. AI drafts, the teacher decides.</a:t>
+              <a:t>Two promises: not a sales pitch (skeptics are important here), not a scare session. Position: AI is a tool: it can take the robotic parts of the job, never the human parts. Then read Kate’s graduation-speech story from the script: ChatGPT nailed the length and timing but wasn’t age-appropriate or personal; she reworked it herself to fit her class, and nothing about her students ever went into the tool. AI drafts, the teacher decides.</a:t>
             </a:r>
             <a:endParaRPr lang="en-US" dirty="0"/>
           </a:p>
@@ -1675,7 +1675,7 @@
           <a:p>
             <a:r>
               <a:rPr lang="en-US" dirty="0"/>
-              <a:t>Circulate. Stuck pairs → option A, it works for every role. Deputize power users to float. Option D is Adam Spinozzi’s own prompt from his carpentry room; say so, and invite electives staff to swap in their station or lab.</a:t>
+              <a:t>Circulate. Stuck pairs → option A, it works for every role. Deputize power users to float. Option D is Adam’s own prompt from his carpentry room; say so, and invite electives staff to swap in their station or lab.</a:t>
             </a:r>
             <a:endParaRPr lang="en-US" dirty="0"/>
           </a:p>
@@ -2027,7 +2027,7 @@
           <a:p>
             <a:r>
               <a:rPr lang="en-US" dirty="0"/>
-              <a:t>Nobody selling AI leads with these. Naming them is what earns the room’s trust. Then read the two author passages from the script: Adam Spinozzi’s table-saw story (his student caught a kickback setup by eye, from experience, not from AI) and the authors’ shared take: over-reliance is the biggest risk; students must identify the problem and the tools before AI helps.</a:t>
+              <a:t>Nobody selling AI leads with these. Naming them is what earns the room’s trust. Then read the two author passages from the script: Adam’s table-saw story (his student caught a kickback setup by eye, from experience, not from AI) and the authors’ shared take: over-reliance is the biggest risk; students must identify the problem and the tools before AI helps.</a:t>
             </a:r>
             <a:endParaRPr lang="en-US" dirty="0"/>
           </a:p>

</xml_diff>

<commit_message>
Owner directive: decks direct the PD without the script
Audit of all five decks under a new KIT_STANDARD rule (self-standing decks):
Kits 3-5 already met the bar; Kit 1 slide 19 and Kit 2 slide 13 gained on-slide
answer strips for their audience-practice prompts, and five stage-direction-only
speaker notes across Kits 1-4 now open with 'Say:' delivery content. Rule and
audit outcome recorded in KIT_STANDARD, DECISIONS, and per-kit provenance.
Decks 1-4 rebuilt and re-inspected; Kit 5 unchanged (already compliant).

Co-Authored-By: Claude Fable 5 <noreply@anthropic.com>
Claude-Session: https://claude.ai/code/session_01EsE79TDyHfL767rcqG6D4Q
</commit_message>
<xml_diff>
--- a/kits/kit01/Kit01_PresentationDeck.pptx
+++ b/kits/kit01/Kit01_PresentationDeck.pptx
@@ -1411,7 +1411,7 @@
           <a:p>
             <a:r>
               <a:rPr lang="en-US" dirty="0"/>
-              <a:t>Answers: A unsafe (initials + IEP contents). B safe. C unsafe: no name, but "the student who just moved here from Ukraine" identifies a child; fix: "a student who recently arrived from another country and is learning English." D safe: aggregate, no identities. Prompt C splits the room on purpose; resolve with the slide-12 test. 3 minutes, brisk.</a:t>
+              <a:t>Let the room call each one before you confirm with the answer line at the bottom. C is the splitter: no name, but "the student who just moved here from Ukraine" identifies a child; fix: "a student who recently arrived from another country and is learning English." Resolve debates with the slide-12 test. 3 minutes, brisk.</a:t>
             </a:r>
             <a:endParaRPr lang="en-US" dirty="0"/>
           </a:p>
@@ -1587,7 +1587,7 @@
           <a:p>
             <a:r>
               <a:rPr lang="en-US" dirty="0"/>
-              <a:t>Energy up: this is the moment the session exists for. Announce the tool by name. Pairs formed inside two minutes.</a:t>
+              <a:t>Say: this is the moment the session exists for; everything so far was preparation for you actually typing. Nothing has to be good, it's a sandbox, and we practice like we play: zero student information. Announce the tool by name. Energy up; pairs formed inside two minutes.</a:t>
             </a:r>
             <a:endParaRPr lang="en-US" dirty="0"/>
           </a:p>
@@ -3083,7 +3083,7 @@
           <a:p>
             <a:r>
               <a:rPr lang="en-US" dirty="0"/>
-              <a:t>This is the session’s first explicit "human moment." Land it plainly and move on.</a:t>
+              <a:t>Say: nothing on this list is under threat, on purpose and forever. AI can't know your students, can't verify its own facts, and can't care. The tool buys back time FOR this list; it never takes this list away. This is the session's first explicit "human moment"; land it plainly and move on.</a:t>
             </a:r>
             <a:endParaRPr lang="en-US" dirty="0"/>
           </a:p>
@@ -9015,6 +9015,45 @@
           </a:p>
         </p:txBody>
       </p:sp>
+      <p:sp>
+        <p:nvSpPr>
+          <p:cNvPr id="23" name="Text 20"/>
+          <p:cNvSpPr/>
+          <p:nvPr/>
+        </p:nvSpPr>
+        <p:spPr>
+          <a:xfrm>
+            <a:off x="640080" y="5806440"/>
+            <a:ext cx="10972800" cy="365760"/>
+          </a:xfrm>
+          <a:prstGeom prst="rect">
+            <a:avLst/>
+          </a:prstGeom>
+          <a:noFill/>
+          <a:ln/>
+        </p:spPr>
+        <p:txBody>
+          <a:bodyPr wrap="square" lIns="0" tIns="0" rIns="0" bIns="0" rtlCol="0" anchor="ctr"/>
+          <a:lstStyle/>
+          <a:p>
+            <a:pPr algn="ctr" indent="0" marL="0">
+              <a:buNone/>
+            </a:pPr>
+            <a:r>
+              <a:rPr lang="en-US" sz="1350" i="1" dirty="0">
+                <a:solidFill>
+                  <a:srgbClr val="5B6B7A"/>
+                </a:solidFill>
+                <a:latin typeface="Inter" pitchFamily="34" charset="0"/>
+                <a:ea typeface="Inter" pitchFamily="34" charset="-122"/>
+                <a:cs typeface="Inter" pitchFamily="34" charset="-120"/>
+              </a:rPr>
+              <a:t>Answers: A unsafe (initials + IEP details) · B safe · C unsafe (identifiable without a name) · D safe (aggregate, no identities)</a:t>
+            </a:r>
+            <a:endParaRPr lang="en-US" sz="1350" dirty="0"/>
+          </a:p>
+        </p:txBody>
+      </p:sp>
     </p:spTree>
   </p:cSld>
   <p:clrMapOvr>

</xml_diff>

<commit_message>
Owner directive: running teacher exemplar (Ms. Rivera) across all decks
Every deck now shows the same composite teacher's screen at its flagship
worked-example moment: a generic chat window (no vendor trade dress) with the
prompt's role/task/context/format color-coded and labeled by legend chips.
Kit 1 also shows her safe-swap and pushback replies as chat moments; Kit 5
pairs the expectation-box template with her finished box. Rule recorded in
KIT_STANDARD and DECISIONS; per-kit provenance updated; all five decks rebuilt
and visually verified.

Co-Authored-By: Claude Fable 5 <noreply@anthropic.com>
Claude-Session: https://claude.ai/code/session_01EsE79TDyHfL767rcqG6D4Q
</commit_message>
<xml_diff>
--- a/kits/kit01/Kit01_PresentationDeck.pptx
+++ b/kits/kit01/Kit01_PresentationDeck.pptx
@@ -1147,7 +1147,7 @@
           <a:p>
             <a:r>
               <a:rPr lang="en-US" dirty="0"/>
-              <a:t>The unsafe version pastes a full student record (name, family, academics, behavior) into a stranger’s text box. The safe version gets the same email; the AI needed the situation, never the child. Add the name after it’s back in your own email account.</a:t>
+              <a:t>Say: this is Ms. Rivera, our running example teacher; she's a composite, and her screen shows what this looks like on your end. The unsafe version pastes a full student record (name, family, academics, behavior) into a stranger's text box. The safe version gets the same email; the AI needed the situation, never the child. She adds the name after it's back in her own email account.</a:t>
             </a:r>
             <a:endParaRPr lang="en-US" dirty="0"/>
           </a:p>
@@ -1763,7 +1763,7 @@
           <a:p>
             <a:r>
               <a:rPr lang="en-US" dirty="0"/>
-              <a:t>45-minute version: skip this task, go straight to the debrief. This is the move that separates people who get real value from people who quit in a week.</a:t>
+              <a:t>Say: each of these is a real reply Ms. Rivera types into the chat after the first draft comes back; short and blunt is fine, the tool has no feelings. Push back at least twice on your own draft, the same way. 45-minute version: skip this task, go straight to the debrief. This is the move that separates people who get real value from people who quit in a week.</a:t>
             </a:r>
             <a:endParaRPr lang="en-US" dirty="0"/>
           </a:p>
@@ -6759,7 +6759,7 @@
                 <a:ea typeface="Inter" pitchFamily="34" charset="-122"/>
                 <a:cs typeface="Inter" pitchFamily="34" charset="-120"/>
               </a:rPr>
-              <a:t>SAME EMAIL, ZERO RISK</a:t>
+              <a:t>SAME EMAIL, ZERO RISK · ON MS. RIVERA'S SCREEN</a:t>
             </a:r>
             <a:endParaRPr lang="en-US" sz="1200" dirty="0"/>
           </a:p>
@@ -6812,12 +6812,180 @@
         </p:nvSpPr>
         <p:spPr>
           <a:xfrm>
-            <a:off x="640080" y="1463040"/>
-            <a:ext cx="10972800" cy="1965960"/>
+            <a:off x="640080" y="1417320"/>
+            <a:ext cx="10972800" cy="4389120"/>
           </a:xfrm>
           <a:prstGeom prst="roundRect">
             <a:avLst>
-              <a:gd name="adj" fmla="val 4186"/>
+              <a:gd name="adj" fmla="val 2083"/>
+            </a:avLst>
+          </a:prstGeom>
+          <a:solidFill>
+            <a:srgbClr val="FFFFFF"/>
+          </a:solidFill>
+          <a:ln w="19050">
+            <a:solidFill>
+              <a:srgbClr val="DCE3EA"/>
+            </a:solidFill>
+            <a:prstDash val="solid"/>
+          </a:ln>
+        </p:spPr>
+      </p:sp>
+      <p:sp>
+        <p:nvSpPr>
+          <p:cNvPr id="8" name="Shape 5"/>
+          <p:cNvSpPr/>
+          <p:nvPr/>
+        </p:nvSpPr>
+        <p:spPr>
+          <a:xfrm>
+            <a:off x="640080" y="1417320"/>
+            <a:ext cx="10972800" cy="384048"/>
+          </a:xfrm>
+          <a:prstGeom prst="roundRect">
+            <a:avLst>
+              <a:gd name="adj" fmla="val 23810"/>
+            </a:avLst>
+          </a:prstGeom>
+          <a:solidFill>
+            <a:srgbClr val="13293D"/>
+          </a:solidFill>
+          <a:ln w="12700">
+            <a:solidFill>
+              <a:srgbClr val="13293D"/>
+            </a:solidFill>
+            <a:prstDash val="solid"/>
+          </a:ln>
+        </p:spPr>
+      </p:sp>
+      <p:sp>
+        <p:nvSpPr>
+          <p:cNvPr id="9" name="Shape 6"/>
+          <p:cNvSpPr/>
+          <p:nvPr/>
+        </p:nvSpPr>
+        <p:spPr>
+          <a:xfrm>
+            <a:off x="868680" y="1536192"/>
+            <a:ext cx="146304" cy="146304"/>
+          </a:xfrm>
+          <a:prstGeom prst="ellipse">
+            <a:avLst/>
+          </a:prstGeom>
+          <a:solidFill>
+            <a:srgbClr val="E8837A"/>
+          </a:solidFill>
+          <a:ln w="12700">
+            <a:solidFill>
+              <a:srgbClr val="E8837A"/>
+            </a:solidFill>
+            <a:prstDash val="solid"/>
+          </a:ln>
+        </p:spPr>
+      </p:sp>
+      <p:sp>
+        <p:nvSpPr>
+          <p:cNvPr id="10" name="Shape 7"/>
+          <p:cNvSpPr/>
+          <p:nvPr/>
+        </p:nvSpPr>
+        <p:spPr>
+          <a:xfrm>
+            <a:off x="1115568" y="1536192"/>
+            <a:ext cx="146304" cy="146304"/>
+          </a:xfrm>
+          <a:prstGeom prst="ellipse">
+            <a:avLst/>
+          </a:prstGeom>
+          <a:solidFill>
+            <a:srgbClr val="F4A825"/>
+          </a:solidFill>
+          <a:ln w="12700">
+            <a:solidFill>
+              <a:srgbClr val="F4A825"/>
+            </a:solidFill>
+            <a:prstDash val="solid"/>
+          </a:ln>
+        </p:spPr>
+      </p:sp>
+      <p:sp>
+        <p:nvSpPr>
+          <p:cNvPr id="11" name="Shape 8"/>
+          <p:cNvSpPr/>
+          <p:nvPr/>
+        </p:nvSpPr>
+        <p:spPr>
+          <a:xfrm>
+            <a:off x="1362456" y="1536192"/>
+            <a:ext cx="146304" cy="146304"/>
+          </a:xfrm>
+          <a:prstGeom prst="ellipse">
+            <a:avLst/>
+          </a:prstGeom>
+          <a:solidFill>
+            <a:srgbClr val="2E7D5B"/>
+          </a:solidFill>
+          <a:ln w="12700">
+            <a:solidFill>
+              <a:srgbClr val="2E7D5B"/>
+            </a:solidFill>
+            <a:prstDash val="solid"/>
+          </a:ln>
+        </p:spPr>
+      </p:sp>
+      <p:sp>
+        <p:nvSpPr>
+          <p:cNvPr id="12" name="Text 9"/>
+          <p:cNvSpPr/>
+          <p:nvPr/>
+        </p:nvSpPr>
+        <p:spPr>
+          <a:xfrm>
+            <a:off x="1783080" y="1417320"/>
+            <a:ext cx="9692640" cy="384048"/>
+          </a:xfrm>
+          <a:prstGeom prst="rect">
+            <a:avLst/>
+          </a:prstGeom>
+          <a:noFill/>
+          <a:ln/>
+        </p:spPr>
+        <p:txBody>
+          <a:bodyPr wrap="square" lIns="0" tIns="0" rIns="0" bIns="0" rtlCol="0" anchor="ctr"/>
+          <a:lstStyle/>
+          <a:p>
+            <a:pPr indent="0" marL="0">
+              <a:buNone/>
+            </a:pPr>
+            <a:r>
+              <a:rPr lang="en-US" sz="1100" dirty="0">
+                <a:solidFill>
+                  <a:srgbClr val="9FB2C2"/>
+                </a:solidFill>
+                <a:latin typeface="Inter" pitchFamily="34" charset="0"/>
+                <a:ea typeface="Inter" pitchFamily="34" charset="-122"/>
+                <a:cs typeface="Inter" pitchFamily="34" charset="-120"/>
+              </a:rPr>
+              <a:t>AI chat tool (any of them) · Ms. Rivera, our running example teacher (a composite, not a real person)</a:t>
+            </a:r>
+            <a:endParaRPr lang="en-US" sz="1100" dirty="0"/>
+          </a:p>
+        </p:txBody>
+      </p:sp>
+      <p:sp>
+        <p:nvSpPr>
+          <p:cNvPr id="13" name="Shape 10"/>
+          <p:cNvSpPr/>
+          <p:nvPr/>
+        </p:nvSpPr>
+        <p:spPr>
+          <a:xfrm>
+            <a:off x="1554480" y="2011680"/>
+            <a:ext cx="9646920" cy="1463040"/>
+          </a:xfrm>
+          <a:prstGeom prst="roundRect">
+            <a:avLst>
+              <a:gd name="adj" fmla="val 7500"/>
             </a:avLst>
           </a:prstGeom>
           <a:solidFill>
@@ -6833,30 +7001,30 @@
       </p:sp>
       <p:sp>
         <p:nvSpPr>
-          <p:cNvPr id="8" name="Text 5"/>
-          <p:cNvSpPr/>
-          <p:nvPr/>
-        </p:nvSpPr>
-        <p:spPr>
-          <a:xfrm>
-            <a:off x="914400" y="1627632"/>
-            <a:ext cx="1828800" cy="320040"/>
-          </a:xfrm>
-          <a:prstGeom prst="rect">
-            <a:avLst/>
-          </a:prstGeom>
-          <a:noFill/>
-          <a:ln/>
-        </p:spPr>
-        <p:txBody>
-          <a:bodyPr wrap="square" lIns="0" tIns="0" rIns="0" bIns="0" rtlCol="0" anchor="ctr"/>
-          <a:lstStyle/>
-          <a:p>
-            <a:pPr indent="0" marL="0">
-              <a:buNone/>
-            </a:pPr>
-            <a:r>
-              <a:rPr lang="en-US" sz="1400" b="1" dirty="0">
+          <p:cNvPr id="14" name="Text 11"/>
+          <p:cNvSpPr/>
+          <p:nvPr/>
+        </p:nvSpPr>
+        <p:spPr>
+          <a:xfrm>
+            <a:off x="1783080" y="2121408"/>
+            <a:ext cx="9144000" cy="274320"/>
+          </a:xfrm>
+          <a:prstGeom prst="rect">
+            <a:avLst/>
+          </a:prstGeom>
+          <a:noFill/>
+          <a:ln/>
+        </p:spPr>
+        <p:txBody>
+          <a:bodyPr wrap="square" lIns="0" tIns="0" rIns="0" bIns="0" rtlCol="0" anchor="ctr"/>
+          <a:lstStyle/>
+          <a:p>
+            <a:pPr indent="0" marL="0">
+              <a:buNone/>
+            </a:pPr>
+            <a:r>
+              <a:rPr lang="en-US" sz="1150" b="1" spc="150" kern="0" dirty="0">
                 <a:solidFill>
                   <a:srgbClr val="B4453A"/>
                 </a:solidFill>
@@ -6864,38 +7032,38 @@
                 <a:ea typeface="Inter" pitchFamily="34" charset="-122"/>
                 <a:cs typeface="Inter" pitchFamily="34" charset="-120"/>
               </a:rPr>
-              <a:t>UNSAFE</a:t>
-            </a:r>
-            <a:endParaRPr lang="en-US" sz="1400" dirty="0"/>
-          </a:p>
-        </p:txBody>
-      </p:sp>
-      <p:sp>
-        <p:nvSpPr>
-          <p:cNvPr id="9" name="Text 6"/>
-          <p:cNvSpPr/>
-          <p:nvPr/>
-        </p:nvSpPr>
-        <p:spPr>
-          <a:xfrm>
-            <a:off x="914400" y="1965960"/>
-            <a:ext cx="10424160" cy="1280160"/>
-          </a:xfrm>
-          <a:prstGeom prst="rect">
-            <a:avLst/>
-          </a:prstGeom>
-          <a:noFill/>
-          <a:ln/>
-        </p:spPr>
-        <p:txBody>
-          <a:bodyPr wrap="square" lIns="0" tIns="0" rIns="0" bIns="0" rtlCol="0" anchor="ctr"/>
-          <a:lstStyle/>
-          <a:p>
-            <a:pPr indent="0" marL="0">
-              <a:buNone/>
-            </a:pPr>
-            <a:r>
-              <a:rPr lang="en-US" sz="1900" i="1" dirty="0">
+              <a:t>WHAT SHE ALMOST TYPED · UNSAFE</a:t>
+            </a:r>
+            <a:endParaRPr lang="en-US" sz="1150" dirty="0"/>
+          </a:p>
+        </p:txBody>
+      </p:sp>
+      <p:sp>
+        <p:nvSpPr>
+          <p:cNvPr id="15" name="Text 12"/>
+          <p:cNvSpPr/>
+          <p:nvPr/>
+        </p:nvSpPr>
+        <p:spPr>
+          <a:xfrm>
+            <a:off x="1783080" y="2414016"/>
+            <a:ext cx="9189720" cy="1005840"/>
+          </a:xfrm>
+          <a:prstGeom prst="rect">
+            <a:avLst/>
+          </a:prstGeom>
+          <a:noFill/>
+          <a:ln/>
+        </p:spPr>
+        <p:txBody>
+          <a:bodyPr wrap="square" lIns="0" tIns="0" rIns="0" bIns="0" rtlCol="0" anchor="ctr"/>
+          <a:lstStyle/>
+          <a:p>
+            <a:pPr indent="0" marL="0">
+              <a:buNone/>
+            </a:pPr>
+            <a:r>
+              <a:rPr lang="en-US" sz="1700" i="1" dirty="0">
                 <a:solidFill>
                   <a:srgbClr val="1B1F24"/>
                 </a:solidFill>
@@ -6905,24 +7073,24 @@
               </a:rPr>
               <a:t>“Write an email to Jayden Miller’s mom about his three missing assignments and his outburst in class Tuesday.”</a:t>
             </a:r>
-            <a:endParaRPr lang="en-US" sz="1900" dirty="0"/>
-          </a:p>
-        </p:txBody>
-      </p:sp>
-      <p:sp>
-        <p:nvSpPr>
-          <p:cNvPr id="10" name="Shape 7"/>
-          <p:cNvSpPr/>
-          <p:nvPr/>
-        </p:nvSpPr>
-        <p:spPr>
-          <a:xfrm>
-            <a:off x="640080" y="3657600"/>
-            <a:ext cx="10972800" cy="2148840"/>
+            <a:endParaRPr lang="en-US" sz="1700" dirty="0"/>
+          </a:p>
+        </p:txBody>
+      </p:sp>
+      <p:sp>
+        <p:nvSpPr>
+          <p:cNvPr id="16" name="Shape 13"/>
+          <p:cNvSpPr/>
+          <p:nvPr/>
+        </p:nvSpPr>
+        <p:spPr>
+          <a:xfrm>
+            <a:off x="1554480" y="3657600"/>
+            <a:ext cx="9646920" cy="1920240"/>
           </a:xfrm>
           <a:prstGeom prst="roundRect">
             <a:avLst>
-              <a:gd name="adj" fmla="val 3830"/>
+              <a:gd name="adj" fmla="val 5714"/>
             </a:avLst>
           </a:prstGeom>
           <a:solidFill>
@@ -6938,30 +7106,30 @@
       </p:sp>
       <p:sp>
         <p:nvSpPr>
-          <p:cNvPr id="11" name="Text 8"/>
-          <p:cNvSpPr/>
-          <p:nvPr/>
-        </p:nvSpPr>
-        <p:spPr>
-          <a:xfrm>
-            <a:off x="914400" y="3822192"/>
-            <a:ext cx="1828800" cy="320040"/>
-          </a:xfrm>
-          <a:prstGeom prst="rect">
-            <a:avLst/>
-          </a:prstGeom>
-          <a:noFill/>
-          <a:ln/>
-        </p:spPr>
-        <p:txBody>
-          <a:bodyPr wrap="square" lIns="0" tIns="0" rIns="0" bIns="0" rtlCol="0" anchor="ctr"/>
-          <a:lstStyle/>
-          <a:p>
-            <a:pPr indent="0" marL="0">
-              <a:buNone/>
-            </a:pPr>
-            <a:r>
-              <a:rPr lang="en-US" sz="1400" b="1" dirty="0">
+          <p:cNvPr id="17" name="Text 14"/>
+          <p:cNvSpPr/>
+          <p:nvPr/>
+        </p:nvSpPr>
+        <p:spPr>
+          <a:xfrm>
+            <a:off x="1783080" y="3767328"/>
+            <a:ext cx="9144000" cy="274320"/>
+          </a:xfrm>
+          <a:prstGeom prst="rect">
+            <a:avLst/>
+          </a:prstGeom>
+          <a:noFill/>
+          <a:ln/>
+        </p:spPr>
+        <p:txBody>
+          <a:bodyPr wrap="square" lIns="0" tIns="0" rIns="0" bIns="0" rtlCol="0" anchor="ctr"/>
+          <a:lstStyle/>
+          <a:p>
+            <a:pPr indent="0" marL="0">
+              <a:buNone/>
+            </a:pPr>
+            <a:r>
+              <a:rPr lang="en-US" sz="1150" b="1" spc="150" kern="0" dirty="0">
                 <a:solidFill>
                   <a:srgbClr val="2E7D5B"/>
                 </a:solidFill>
@@ -6969,38 +7137,38 @@
                 <a:ea typeface="Inter" pitchFamily="34" charset="-122"/>
                 <a:cs typeface="Inter" pitchFamily="34" charset="-120"/>
               </a:rPr>
-              <a:t>SAFE</a:t>
-            </a:r>
-            <a:endParaRPr lang="en-US" sz="1400" dirty="0"/>
-          </a:p>
-        </p:txBody>
-      </p:sp>
-      <p:sp>
-        <p:nvSpPr>
-          <p:cNvPr id="12" name="Text 9"/>
-          <p:cNvSpPr/>
-          <p:nvPr/>
-        </p:nvSpPr>
-        <p:spPr>
-          <a:xfrm>
-            <a:off x="914400" y="4160520"/>
-            <a:ext cx="10424160" cy="1554480"/>
-          </a:xfrm>
-          <a:prstGeom prst="rect">
-            <a:avLst/>
-          </a:prstGeom>
-          <a:noFill/>
-          <a:ln/>
-        </p:spPr>
-        <p:txBody>
-          <a:bodyPr wrap="square" lIns="0" tIns="0" rIns="0" bIns="0" rtlCol="0" anchor="ctr"/>
-          <a:lstStyle/>
-          <a:p>
-            <a:pPr indent="0" marL="0">
-              <a:buNone/>
-            </a:pPr>
-            <a:r>
-              <a:rPr lang="en-US" sz="1900" i="1" dirty="0">
+              <a:t>WHAT SHE SENT · SAFE</a:t>
+            </a:r>
+            <a:endParaRPr lang="en-US" sz="1150" dirty="0"/>
+          </a:p>
+        </p:txBody>
+      </p:sp>
+      <p:sp>
+        <p:nvSpPr>
+          <p:cNvPr id="18" name="Text 15"/>
+          <p:cNvSpPr/>
+          <p:nvPr/>
+        </p:nvSpPr>
+        <p:spPr>
+          <a:xfrm>
+            <a:off x="1783080" y="4059936"/>
+            <a:ext cx="9189720" cy="1417320"/>
+          </a:xfrm>
+          <a:prstGeom prst="rect">
+            <a:avLst/>
+          </a:prstGeom>
+          <a:noFill/>
+          <a:ln/>
+        </p:spPr>
+        <p:txBody>
+          <a:bodyPr wrap="square" lIns="0" tIns="0" rIns="0" bIns="0" rtlCol="0" anchor="ctr"/>
+          <a:lstStyle/>
+          <a:p>
+            <a:pPr indent="0" marL="0">
+              <a:buNone/>
+            </a:pPr>
+            <a:r>
+              <a:rPr lang="en-US" sz="1700" i="1" dirty="0">
                 <a:solidFill>
                   <a:srgbClr val="1B1F24"/>
                 </a:solidFill>
@@ -7010,7 +7178,46 @@
               </a:rPr>
               <a:t>“Write a warm, professional email to a parent about a middle schooler with several missing assignments and a recent difficult day in class. Firm but supportive; end by inviting a conversation.”</a:t>
             </a:r>
-            <a:endParaRPr lang="en-US" sz="1900" dirty="0"/>
+            <a:endParaRPr lang="en-US" sz="1700" dirty="0"/>
+          </a:p>
+        </p:txBody>
+      </p:sp>
+      <p:sp>
+        <p:nvSpPr>
+          <p:cNvPr id="19" name="Text 16"/>
+          <p:cNvSpPr/>
+          <p:nvPr/>
+        </p:nvSpPr>
+        <p:spPr>
+          <a:xfrm>
+            <a:off x="640080" y="5897880"/>
+            <a:ext cx="10972800" cy="365760"/>
+          </a:xfrm>
+          <a:prstGeom prst="rect">
+            <a:avLst/>
+          </a:prstGeom>
+          <a:noFill/>
+          <a:ln/>
+        </p:spPr>
+        <p:txBody>
+          <a:bodyPr wrap="square" lIns="0" tIns="0" rIns="0" bIns="0" rtlCol="0" anchor="ctr"/>
+          <a:lstStyle/>
+          <a:p>
+            <a:pPr algn="ctr" indent="0" marL="0">
+              <a:buNone/>
+            </a:pPr>
+            <a:r>
+              <a:rPr lang="en-US" sz="1600" b="1" dirty="0">
+                <a:solidFill>
+                  <a:srgbClr val="13293D"/>
+                </a:solidFill>
+                <a:latin typeface="Inter" pitchFamily="34" charset="0"/>
+                <a:ea typeface="Inter" pitchFamily="34" charset="-122"/>
+                <a:cs typeface="Inter" pitchFamily="34" charset="-120"/>
+              </a:rPr>
+              <a:t>Same email out the other end. The AI needed the situation, never the child.</a:t>
+            </a:r>
+            <a:endParaRPr lang="en-US" sz="1600" dirty="0"/>
           </a:p>
         </p:txBody>
       </p:sp>
@@ -11278,7 +11485,7 @@
                 <a:ea typeface="Inter" pitchFamily="34" charset="-122"/>
                 <a:cs typeface="Inter" pitchFamily="34" charset="-120"/>
               </a:rPr>
-              <a:t>LAB · TASK 2 OF 2 · 6 MINUTES</a:t>
+              <a:t>LAB · TASK 2 OF 2 · 6 MINUTES · HOW MS. RIVERA DOES IT</a:t>
             </a:r>
             <a:endParaRPr lang="en-US" sz="1200" dirty="0"/>
           </a:p>
@@ -11331,7 +11538,7 @@
         </p:nvSpPr>
         <p:spPr>
           <a:xfrm>
-            <a:off x="640080" y="1417320"/>
+            <a:off x="640080" y="1371600"/>
             <a:ext cx="10972800" cy="502920"/>
           </a:xfrm>
           <a:prstGeom prst="rect">
@@ -11348,7 +11555,7 @@
               <a:buNone/>
             </a:pPr>
             <a:r>
-              <a:rPr lang="en-US" sz="2100" dirty="0">
+              <a:rPr lang="en-US" sz="2000" dirty="0">
                 <a:solidFill>
                   <a:srgbClr val="1B1F24"/>
                 </a:solidFill>
@@ -11356,9 +11563,9 @@
                 <a:ea typeface="Inter" pitchFamily="34" charset="-122"/>
                 <a:cs typeface="Inter" pitchFamily="34" charset="-120"/>
               </a:rPr>
-              <a:t>Don’t accept the first draft. Tell it what’s wrong, like you would an intern:</a:t>
-            </a:r>
-            <a:endParaRPr lang="en-US" sz="2100" dirty="0"/>
+              <a:t>Don’t accept the first draft. Tell it what’s wrong, like you would an intern. Ms. Rivera’s replies, one at a time:</a:t>
+            </a:r>
+            <a:endParaRPr lang="en-US" sz="2000" dirty="0"/>
           </a:p>
         </p:txBody>
       </p:sp>
@@ -11370,12 +11577,12 @@
         </p:nvSpPr>
         <p:spPr>
           <a:xfrm>
-            <a:off x="1097280" y="2148840"/>
-            <a:ext cx="10058400" cy="713232"/>
+            <a:off x="3291840" y="2103120"/>
+            <a:ext cx="7863840" cy="713232"/>
           </a:xfrm>
           <a:prstGeom prst="roundRect">
             <a:avLst>
-              <a:gd name="adj" fmla="val 11538"/>
+              <a:gd name="adj" fmla="val 15385"/>
             </a:avLst>
           </a:prstGeom>
           <a:solidFill>
@@ -11397,8 +11604,8 @@
         </p:nvSpPr>
         <p:spPr>
           <a:xfrm>
-            <a:off x="1417320" y="2194560"/>
-            <a:ext cx="9418320" cy="621792"/>
+            <a:off x="3611880" y="2148840"/>
+            <a:ext cx="7315200" cy="621792"/>
           </a:xfrm>
           <a:prstGeom prst="rect">
             <a:avLst/>
@@ -11430,18 +11637,57 @@
       </p:sp>
       <p:sp>
         <p:nvSpPr>
-          <p:cNvPr id="10" name="Shape 7"/>
-          <p:cNvSpPr/>
-          <p:nvPr/>
-        </p:nvSpPr>
-        <p:spPr>
-          <a:xfrm>
-            <a:off x="1097280" y="3017520"/>
-            <a:ext cx="10058400" cy="713232"/>
+          <p:cNvPr id="10" name="Text 7"/>
+          <p:cNvSpPr/>
+          <p:nvPr/>
+        </p:nvSpPr>
+        <p:spPr>
+          <a:xfrm>
+            <a:off x="1965960" y="2148840"/>
+            <a:ext cx="1234440" cy="621792"/>
+          </a:xfrm>
+          <a:prstGeom prst="rect">
+            <a:avLst/>
+          </a:prstGeom>
+          <a:noFill/>
+          <a:ln/>
+        </p:spPr>
+        <p:txBody>
+          <a:bodyPr wrap="square" lIns="0" tIns="0" rIns="0" bIns="0" rtlCol="0" anchor="ctr"/>
+          <a:lstStyle/>
+          <a:p>
+            <a:pPr algn="r" indent="0" marL="0">
+              <a:buNone/>
+            </a:pPr>
+            <a:r>
+              <a:rPr lang="en-US" sz="1200" i="1" dirty="0">
+                <a:solidFill>
+                  <a:srgbClr val="5B6B7A"/>
+                </a:solidFill>
+                <a:latin typeface="Inter" pitchFamily="34" charset="0"/>
+                <a:ea typeface="Inter" pitchFamily="34" charset="-122"/>
+                <a:cs typeface="Inter" pitchFamily="34" charset="-120"/>
+              </a:rPr>
+              <a:t>she types →</a:t>
+            </a:r>
+            <a:endParaRPr lang="en-US" sz="1200" dirty="0"/>
+          </a:p>
+        </p:txBody>
+      </p:sp>
+      <p:sp>
+        <p:nvSpPr>
+          <p:cNvPr id="11" name="Shape 8"/>
+          <p:cNvSpPr/>
+          <p:nvPr/>
+        </p:nvSpPr>
+        <p:spPr>
+          <a:xfrm>
+            <a:off x="3291840" y="2971800"/>
+            <a:ext cx="7863840" cy="713232"/>
           </a:xfrm>
           <a:prstGeom prst="roundRect">
             <a:avLst>
-              <a:gd name="adj" fmla="val 11538"/>
+              <a:gd name="adj" fmla="val 15385"/>
             </a:avLst>
           </a:prstGeom>
           <a:solidFill>
@@ -11457,14 +11703,14 @@
       </p:sp>
       <p:sp>
         <p:nvSpPr>
-          <p:cNvPr id="11" name="Text 8"/>
-          <p:cNvSpPr/>
-          <p:nvPr/>
-        </p:nvSpPr>
-        <p:spPr>
-          <a:xfrm>
-            <a:off x="1417320" y="3063240"/>
-            <a:ext cx="9418320" cy="621792"/>
+          <p:cNvPr id="12" name="Text 9"/>
+          <p:cNvSpPr/>
+          <p:nvPr/>
+        </p:nvSpPr>
+        <p:spPr>
+          <a:xfrm>
+            <a:off x="3611880" y="3017520"/>
+            <a:ext cx="7315200" cy="621792"/>
           </a:xfrm>
           <a:prstGeom prst="rect">
             <a:avLst/>
@@ -11496,18 +11742,57 @@
       </p:sp>
       <p:sp>
         <p:nvSpPr>
-          <p:cNvPr id="12" name="Shape 9"/>
-          <p:cNvSpPr/>
-          <p:nvPr/>
-        </p:nvSpPr>
-        <p:spPr>
-          <a:xfrm>
-            <a:off x="1097280" y="3886200"/>
-            <a:ext cx="10058400" cy="713232"/>
+          <p:cNvPr id="13" name="Text 10"/>
+          <p:cNvSpPr/>
+          <p:nvPr/>
+        </p:nvSpPr>
+        <p:spPr>
+          <a:xfrm>
+            <a:off x="1965960" y="3017520"/>
+            <a:ext cx="1234440" cy="621792"/>
+          </a:xfrm>
+          <a:prstGeom prst="rect">
+            <a:avLst/>
+          </a:prstGeom>
+          <a:noFill/>
+          <a:ln/>
+        </p:spPr>
+        <p:txBody>
+          <a:bodyPr wrap="square" lIns="0" tIns="0" rIns="0" bIns="0" rtlCol="0" anchor="ctr"/>
+          <a:lstStyle/>
+          <a:p>
+            <a:pPr algn="r" indent="0" marL="0">
+              <a:buNone/>
+            </a:pPr>
+            <a:r>
+              <a:rPr lang="en-US" sz="1200" i="1" dirty="0">
+                <a:solidFill>
+                  <a:srgbClr val="5B6B7A"/>
+                </a:solidFill>
+                <a:latin typeface="Inter" pitchFamily="34" charset="0"/>
+                <a:ea typeface="Inter" pitchFamily="34" charset="-122"/>
+                <a:cs typeface="Inter" pitchFamily="34" charset="-120"/>
+              </a:rPr>
+              <a:t>she types →</a:t>
+            </a:r>
+            <a:endParaRPr lang="en-US" sz="1200" dirty="0"/>
+          </a:p>
+        </p:txBody>
+      </p:sp>
+      <p:sp>
+        <p:nvSpPr>
+          <p:cNvPr id="14" name="Shape 11"/>
+          <p:cNvSpPr/>
+          <p:nvPr/>
+        </p:nvSpPr>
+        <p:spPr>
+          <a:xfrm>
+            <a:off x="3291840" y="3840480"/>
+            <a:ext cx="7863840" cy="713232"/>
           </a:xfrm>
           <a:prstGeom prst="roundRect">
             <a:avLst>
-              <a:gd name="adj" fmla="val 11538"/>
+              <a:gd name="adj" fmla="val 15385"/>
             </a:avLst>
           </a:prstGeom>
           <a:solidFill>
@@ -11523,14 +11808,14 @@
       </p:sp>
       <p:sp>
         <p:nvSpPr>
-          <p:cNvPr id="13" name="Text 10"/>
-          <p:cNvSpPr/>
-          <p:nvPr/>
-        </p:nvSpPr>
-        <p:spPr>
-          <a:xfrm>
-            <a:off x="1417320" y="3931920"/>
-            <a:ext cx="9418320" cy="621792"/>
+          <p:cNvPr id="15" name="Text 12"/>
+          <p:cNvSpPr/>
+          <p:nvPr/>
+        </p:nvSpPr>
+        <p:spPr>
+          <a:xfrm>
+            <a:off x="3611880" y="3886200"/>
+            <a:ext cx="7315200" cy="621792"/>
           </a:xfrm>
           <a:prstGeom prst="rect">
             <a:avLst/>
@@ -11554,7 +11839,7 @@
                 <a:ea typeface="Inter" pitchFamily="34" charset="-122"/>
                 <a:cs typeface="Inter" pitchFamily="34" charset="-120"/>
               </a:rPr>
-              <a:t>“A 5th grader wouldn’t know three of these words — fix that.”</a:t>
+              <a:t>“A 5th grader wouldn’t know three of these words. Fix that.”</a:t>
             </a:r>
             <a:endParaRPr lang="en-US" sz="1900" dirty="0"/>
           </a:p>
@@ -11562,18 +11847,57 @@
       </p:sp>
       <p:sp>
         <p:nvSpPr>
-          <p:cNvPr id="14" name="Shape 11"/>
-          <p:cNvSpPr/>
-          <p:nvPr/>
-        </p:nvSpPr>
-        <p:spPr>
-          <a:xfrm>
-            <a:off x="1097280" y="4754880"/>
-            <a:ext cx="10058400" cy="713232"/>
+          <p:cNvPr id="16" name="Text 13"/>
+          <p:cNvSpPr/>
+          <p:nvPr/>
+        </p:nvSpPr>
+        <p:spPr>
+          <a:xfrm>
+            <a:off x="1965960" y="3886200"/>
+            <a:ext cx="1234440" cy="621792"/>
+          </a:xfrm>
+          <a:prstGeom prst="rect">
+            <a:avLst/>
+          </a:prstGeom>
+          <a:noFill/>
+          <a:ln/>
+        </p:spPr>
+        <p:txBody>
+          <a:bodyPr wrap="square" lIns="0" tIns="0" rIns="0" bIns="0" rtlCol="0" anchor="ctr"/>
+          <a:lstStyle/>
+          <a:p>
+            <a:pPr algn="r" indent="0" marL="0">
+              <a:buNone/>
+            </a:pPr>
+            <a:r>
+              <a:rPr lang="en-US" sz="1200" i="1" dirty="0">
+                <a:solidFill>
+                  <a:srgbClr val="5B6B7A"/>
+                </a:solidFill>
+                <a:latin typeface="Inter" pitchFamily="34" charset="0"/>
+                <a:ea typeface="Inter" pitchFamily="34" charset="-122"/>
+                <a:cs typeface="Inter" pitchFamily="34" charset="-120"/>
+              </a:rPr>
+              <a:t>she types →</a:t>
+            </a:r>
+            <a:endParaRPr lang="en-US" sz="1200" dirty="0"/>
+          </a:p>
+        </p:txBody>
+      </p:sp>
+      <p:sp>
+        <p:nvSpPr>
+          <p:cNvPr id="17" name="Shape 14"/>
+          <p:cNvSpPr/>
+          <p:nvPr/>
+        </p:nvSpPr>
+        <p:spPr>
+          <a:xfrm>
+            <a:off x="3291840" y="4709160"/>
+            <a:ext cx="7863840" cy="713232"/>
           </a:xfrm>
           <a:prstGeom prst="roundRect">
             <a:avLst>
-              <a:gd name="adj" fmla="val 11538"/>
+              <a:gd name="adj" fmla="val 15385"/>
             </a:avLst>
           </a:prstGeom>
           <a:solidFill>
@@ -11589,14 +11913,14 @@
       </p:sp>
       <p:sp>
         <p:nvSpPr>
-          <p:cNvPr id="15" name="Text 12"/>
-          <p:cNvSpPr/>
-          <p:nvPr/>
-        </p:nvSpPr>
-        <p:spPr>
-          <a:xfrm>
-            <a:off x="1417320" y="4800600"/>
-            <a:ext cx="9418320" cy="621792"/>
+          <p:cNvPr id="18" name="Text 15"/>
+          <p:cNvSpPr/>
+          <p:nvPr/>
+        </p:nvSpPr>
+        <p:spPr>
+          <a:xfrm>
+            <a:off x="3611880" y="4754880"/>
+            <a:ext cx="7315200" cy="621792"/>
           </a:xfrm>
           <a:prstGeom prst="rect">
             <a:avLst/>
@@ -11628,7 +11952,46 @@
       </p:sp>
       <p:sp>
         <p:nvSpPr>
-          <p:cNvPr id="16" name="Text 13"/>
+          <p:cNvPr id="19" name="Text 16"/>
+          <p:cNvSpPr/>
+          <p:nvPr/>
+        </p:nvSpPr>
+        <p:spPr>
+          <a:xfrm>
+            <a:off x="1965960" y="4754880"/>
+            <a:ext cx="1234440" cy="621792"/>
+          </a:xfrm>
+          <a:prstGeom prst="rect">
+            <a:avLst/>
+          </a:prstGeom>
+          <a:noFill/>
+          <a:ln/>
+        </p:spPr>
+        <p:txBody>
+          <a:bodyPr wrap="square" lIns="0" tIns="0" rIns="0" bIns="0" rtlCol="0" anchor="ctr"/>
+          <a:lstStyle/>
+          <a:p>
+            <a:pPr algn="r" indent="0" marL="0">
+              <a:buNone/>
+            </a:pPr>
+            <a:r>
+              <a:rPr lang="en-US" sz="1200" i="1" dirty="0">
+                <a:solidFill>
+                  <a:srgbClr val="5B6B7A"/>
+                </a:solidFill>
+                <a:latin typeface="Inter" pitchFamily="34" charset="0"/>
+                <a:ea typeface="Inter" pitchFamily="34" charset="-122"/>
+                <a:cs typeface="Inter" pitchFamily="34" charset="-120"/>
+              </a:rPr>
+              <a:t>she types →</a:t>
+            </a:r>
+            <a:endParaRPr lang="en-US" sz="1200" dirty="0"/>
+          </a:p>
+        </p:txBody>
+      </p:sp>
+      <p:sp>
+        <p:nvSpPr>
+          <p:cNvPr id="20" name="Text 17"/>
           <p:cNvSpPr/>
           <p:nvPr/>
         </p:nvSpPr>

</xml_diff>